<commit_message>
Lesson 4 and 5 Complete
</commit_message>
<xml_diff>
--- a/Python/Lesson 04 - File IO/Python File IO.pptx
+++ b/Python/Lesson 04 - File IO/Python File IO.pptx
@@ -6,7 +6,7 @@
     <p:sldMasterId id="2147483694" r:id="rId2"/>
   </p:sldMasterIdLst>
   <p:notesMasterIdLst>
-    <p:notesMasterId r:id="rId26"/>
+    <p:notesMasterId r:id="rId30"/>
   </p:notesMasterIdLst>
   <p:sldIdLst>
     <p:sldId id="284" r:id="rId3"/>
@@ -15,23 +15,27 @@
     <p:sldId id="491" r:id="rId6"/>
     <p:sldId id="492" r:id="rId7"/>
     <p:sldId id="493" r:id="rId8"/>
-    <p:sldId id="494" r:id="rId9"/>
-    <p:sldId id="276" r:id="rId10"/>
-    <p:sldId id="278" r:id="rId11"/>
-    <p:sldId id="495" r:id="rId12"/>
-    <p:sldId id="498" r:id="rId13"/>
-    <p:sldId id="497" r:id="rId14"/>
-    <p:sldId id="496" r:id="rId15"/>
-    <p:sldId id="279" r:id="rId16"/>
-    <p:sldId id="280" r:id="rId17"/>
-    <p:sldId id="499" r:id="rId18"/>
-    <p:sldId id="261" r:id="rId19"/>
-    <p:sldId id="277" r:id="rId20"/>
-    <p:sldId id="281" r:id="rId21"/>
-    <p:sldId id="282" r:id="rId22"/>
-    <p:sldId id="283" r:id="rId23"/>
-    <p:sldId id="273" r:id="rId24"/>
-    <p:sldId id="259" r:id="rId25"/>
+    <p:sldId id="257" r:id="rId9"/>
+    <p:sldId id="258" r:id="rId10"/>
+    <p:sldId id="500" r:id="rId11"/>
+    <p:sldId id="260" r:id="rId12"/>
+    <p:sldId id="494" r:id="rId13"/>
+    <p:sldId id="276" r:id="rId14"/>
+    <p:sldId id="278" r:id="rId15"/>
+    <p:sldId id="495" r:id="rId16"/>
+    <p:sldId id="498" r:id="rId17"/>
+    <p:sldId id="497" r:id="rId18"/>
+    <p:sldId id="496" r:id="rId19"/>
+    <p:sldId id="279" r:id="rId20"/>
+    <p:sldId id="280" r:id="rId21"/>
+    <p:sldId id="499" r:id="rId22"/>
+    <p:sldId id="261" r:id="rId23"/>
+    <p:sldId id="277" r:id="rId24"/>
+    <p:sldId id="281" r:id="rId25"/>
+    <p:sldId id="282" r:id="rId26"/>
+    <p:sldId id="283" r:id="rId27"/>
+    <p:sldId id="273" r:id="rId28"/>
+    <p:sldId id="259" r:id="rId29"/>
   </p:sldIdLst>
   <p:sldSz cx="12192000" cy="6858000"/>
   <p:notesSz cx="6858000" cy="9144000"/>
@@ -220,7 +224,7 @@
           <a:p>
             <a:fld id="{941F8BC1-DC94-491B-AA44-0232F744EE98}" type="datetimeFigureOut">
               <a:rPr lang="en-US" smtClean="0"/>
-              <a:t>6/19/2026</a:t>
+              <a:t>6/22/2026</a:t>
             </a:fld>
             <a:endParaRPr lang="en-US"/>
           </a:p>
@@ -609,6 +613,307 @@
 </p:notes>
 </file>
 
+<file path=ppt/notesSlides/notesSlide10.xml><?xml version="1.0" encoding="utf-8"?>
+<p:notes xmlns:a="http://schemas.openxmlformats.org/drawingml/2006/main" xmlns:r="http://schemas.openxmlformats.org/officeDocument/2006/relationships" xmlns:p="http://schemas.openxmlformats.org/presentationml/2006/main" showMasterSp="0" showMasterPhAnim="0">
+  <p:cSld>
+    <p:spTree>
+      <p:nvGrpSpPr>
+        <p:cNvPr id="1" name="Shape 71"/>
+        <p:cNvGrpSpPr/>
+        <p:nvPr/>
+      </p:nvGrpSpPr>
+      <p:grpSpPr>
+        <a:xfrm>
+          <a:off x="0" y="0"/>
+          <a:ext cx="0" cy="0"/>
+          <a:chOff x="0" y="0"/>
+          <a:chExt cx="0" cy="0"/>
+        </a:xfrm>
+      </p:grpSpPr>
+      <p:sp>
+        <p:nvSpPr>
+          <p:cNvPr id="72" name="Google Shape;72;g3715ed335dd_0_5:notes"/>
+          <p:cNvSpPr>
+            <a:spLocks noGrp="1" noRot="1" noChangeAspect="1"/>
+          </p:cNvSpPr>
+          <p:nvPr>
+            <p:ph type="sldImg" idx="2"/>
+          </p:nvPr>
+        </p:nvSpPr>
+        <p:spPr>
+          <a:xfrm>
+            <a:off x="381000" y="685800"/>
+            <a:ext cx="6096000" cy="3429000"/>
+          </a:xfrm>
+          <a:custGeom>
+            <a:avLst/>
+            <a:gdLst/>
+            <a:ahLst/>
+            <a:cxnLst/>
+            <a:rect l="l" t="t" r="r" b="b"/>
+            <a:pathLst>
+              <a:path w="120000" h="120000" extrusionOk="0">
+                <a:moveTo>
+                  <a:pt x="0" y="0"/>
+                </a:moveTo>
+                <a:lnTo>
+                  <a:pt x="120000" y="0"/>
+                </a:lnTo>
+                <a:lnTo>
+                  <a:pt x="120000" y="120000"/>
+                </a:lnTo>
+                <a:lnTo>
+                  <a:pt x="0" y="120000"/>
+                </a:lnTo>
+                <a:close/>
+              </a:path>
+            </a:pathLst>
+          </a:custGeom>
+        </p:spPr>
+      </p:sp>
+      <p:sp>
+        <p:nvSpPr>
+          <p:cNvPr id="73" name="Google Shape;73;g3715ed335dd_0_5:notes"/>
+          <p:cNvSpPr txBox="1">
+            <a:spLocks noGrp="1"/>
+          </p:cNvSpPr>
+          <p:nvPr>
+            <p:ph type="body" idx="1"/>
+          </p:nvPr>
+        </p:nvSpPr>
+        <p:spPr>
+          <a:xfrm>
+            <a:off x="685800" y="4343400"/>
+            <a:ext cx="5486400" cy="4114800"/>
+          </a:xfrm>
+          <a:prstGeom prst="rect">
+            <a:avLst/>
+          </a:prstGeom>
+        </p:spPr>
+        <p:txBody>
+          <a:bodyPr spcFirstLastPara="1" wrap="square" lIns="91425" tIns="91425" rIns="91425" bIns="91425" anchor="t" anchorCtr="0">
+            <a:noAutofit/>
+          </a:bodyPr>
+          <a:lstStyle/>
+          <a:p>
+            <a:pPr marL="0" lvl="0" indent="0" algn="l" rtl="0">
+              <a:spcBef>
+                <a:spcPts val="0"/>
+              </a:spcBef>
+              <a:spcAft>
+                <a:spcPts val="0"/>
+              </a:spcAft>
+              <a:buNone/>
+            </a:pPr>
+            <a:endParaRPr/>
+          </a:p>
+        </p:txBody>
+      </p:sp>
+    </p:spTree>
+  </p:cSld>
+  <p:clrMapOvr>
+    <a:masterClrMapping/>
+  </p:clrMapOvr>
+</p:notes>
+</file>
+
+<file path=ppt/notesSlides/notesSlide11.xml><?xml version="1.0" encoding="utf-8"?>
+<p:notes xmlns:a="http://schemas.openxmlformats.org/drawingml/2006/main" xmlns:r="http://schemas.openxmlformats.org/officeDocument/2006/relationships" xmlns:p="http://schemas.openxmlformats.org/presentationml/2006/main">
+  <p:cSld>
+    <p:spTree>
+      <p:nvGrpSpPr>
+        <p:cNvPr id="1" name="">
+          <a:extLst>
+            <a:ext uri="{FF2B5EF4-FFF2-40B4-BE49-F238E27FC236}">
+              <a16:creationId xmlns:a16="http://schemas.microsoft.com/office/drawing/2014/main" id="{2E9E1876-9A88-AC9A-EEA0-09A5D443F787}"/>
+            </a:ext>
+          </a:extLst>
+        </p:cNvPr>
+        <p:cNvGrpSpPr/>
+        <p:nvPr/>
+      </p:nvGrpSpPr>
+      <p:grpSpPr>
+        <a:xfrm>
+          <a:off x="0" y="0"/>
+          <a:ext cx="0" cy="0"/>
+          <a:chOff x="0" y="0"/>
+          <a:chExt cx="0" cy="0"/>
+        </a:xfrm>
+      </p:grpSpPr>
+      <p:sp>
+        <p:nvSpPr>
+          <p:cNvPr id="2" name="Slide Image Placeholder 1">
+            <a:extLst>
+              <a:ext uri="{FF2B5EF4-FFF2-40B4-BE49-F238E27FC236}">
+                <a16:creationId xmlns:a16="http://schemas.microsoft.com/office/drawing/2014/main" id="{8A48ED5F-1EBB-D3DA-21D1-17A4AC27EB0B}"/>
+              </a:ext>
+            </a:extLst>
+          </p:cNvPr>
+          <p:cNvSpPr>
+            <a:spLocks noGrp="1" noRot="1" noChangeAspect="1"/>
+          </p:cNvSpPr>
+          <p:nvPr>
+            <p:ph type="sldImg"/>
+          </p:nvPr>
+        </p:nvSpPr>
+        <p:spPr>
+          <a:xfrm>
+            <a:off x="381000" y="685800"/>
+            <a:ext cx="6096000" cy="3429000"/>
+          </a:xfrm>
+        </p:spPr>
+      </p:sp>
+      <p:sp>
+        <p:nvSpPr>
+          <p:cNvPr id="3" name="Notes Placeholder 2">
+            <a:extLst>
+              <a:ext uri="{FF2B5EF4-FFF2-40B4-BE49-F238E27FC236}">
+                <a16:creationId xmlns:a16="http://schemas.microsoft.com/office/drawing/2014/main" id="{BDD7F1C4-8BD1-42DE-2251-2E35849A0D89}"/>
+              </a:ext>
+            </a:extLst>
+          </p:cNvPr>
+          <p:cNvSpPr>
+            <a:spLocks noGrp="1"/>
+          </p:cNvSpPr>
+          <p:nvPr>
+            <p:ph type="body" idx="1"/>
+          </p:nvPr>
+        </p:nvSpPr>
+        <p:spPr/>
+        <p:txBody>
+          <a:bodyPr/>
+          <a:lstStyle/>
+          <a:p>
+            <a:endParaRPr lang="en-US" dirty="0"/>
+          </a:p>
+        </p:txBody>
+      </p:sp>
+      <p:sp>
+        <p:nvSpPr>
+          <p:cNvPr id="4" name="Slide Number Placeholder 3">
+            <a:extLst>
+              <a:ext uri="{FF2B5EF4-FFF2-40B4-BE49-F238E27FC236}">
+                <a16:creationId xmlns:a16="http://schemas.microsoft.com/office/drawing/2014/main" id="{0E78741C-CD8D-4A35-2F6E-59CC0DFE77A8}"/>
+              </a:ext>
+            </a:extLst>
+          </p:cNvPr>
+          <p:cNvSpPr>
+            <a:spLocks noGrp="1"/>
+          </p:cNvSpPr>
+          <p:nvPr>
+            <p:ph type="sldNum" sz="quarter" idx="5"/>
+          </p:nvPr>
+        </p:nvSpPr>
+        <p:spPr/>
+        <p:txBody>
+          <a:bodyPr/>
+          <a:lstStyle/>
+          <a:p>
+            <a:fld id="{292570D5-C374-43AE-876B-55C2A221664E}" type="slidenum">
+              <a:rPr lang="en-US" smtClean="0"/>
+              <a:t>11</a:t>
+            </a:fld>
+            <a:endParaRPr lang="en-US"/>
+          </a:p>
+        </p:txBody>
+      </p:sp>
+    </p:spTree>
+    <p:extLst>
+      <p:ext uri="{BB962C8B-B14F-4D97-AF65-F5344CB8AC3E}">
+        <p14:creationId xmlns:p14="http://schemas.microsoft.com/office/powerpoint/2010/main" val="1313543551"/>
+      </p:ext>
+    </p:extLst>
+  </p:cSld>
+  <p:clrMapOvr>
+    <a:masterClrMapping/>
+  </p:clrMapOvr>
+</p:notes>
+</file>
+
+<file path=ppt/notesSlides/notesSlide12.xml><?xml version="1.0" encoding="utf-8"?>
+<p:notes xmlns:a="http://schemas.openxmlformats.org/drawingml/2006/main" xmlns:r="http://schemas.openxmlformats.org/officeDocument/2006/relationships" xmlns:p="http://schemas.openxmlformats.org/presentationml/2006/main">
+  <p:cSld>
+    <p:spTree>
+      <p:nvGrpSpPr>
+        <p:cNvPr id="1" name=""/>
+        <p:cNvGrpSpPr/>
+        <p:nvPr/>
+      </p:nvGrpSpPr>
+      <p:grpSpPr>
+        <a:xfrm>
+          <a:off x="0" y="0"/>
+          <a:ext cx="0" cy="0"/>
+          <a:chOff x="0" y="0"/>
+          <a:chExt cx="0" cy="0"/>
+        </a:xfrm>
+      </p:grpSpPr>
+      <p:sp>
+        <p:nvSpPr>
+          <p:cNvPr id="2" name="Slide Image Placeholder 1"/>
+          <p:cNvSpPr>
+            <a:spLocks noGrp="1" noRot="1" noChangeAspect="1"/>
+          </p:cNvSpPr>
+          <p:nvPr>
+            <p:ph type="sldImg"/>
+          </p:nvPr>
+        </p:nvSpPr>
+        <p:spPr/>
+      </p:sp>
+      <p:sp>
+        <p:nvSpPr>
+          <p:cNvPr id="3" name="Notes Placeholder 2"/>
+          <p:cNvSpPr>
+            <a:spLocks noGrp="1"/>
+          </p:cNvSpPr>
+          <p:nvPr>
+            <p:ph type="body" idx="1"/>
+          </p:nvPr>
+        </p:nvSpPr>
+        <p:spPr/>
+        <p:txBody>
+          <a:bodyPr/>
+          <a:lstStyle/>
+          <a:p>
+            <a:endParaRPr lang="en-US" dirty="0"/>
+          </a:p>
+        </p:txBody>
+      </p:sp>
+      <p:sp>
+        <p:nvSpPr>
+          <p:cNvPr id="4" name="Slide Number Placeholder 3"/>
+          <p:cNvSpPr>
+            <a:spLocks noGrp="1"/>
+          </p:cNvSpPr>
+          <p:nvPr>
+            <p:ph type="sldNum" sz="quarter" idx="5"/>
+          </p:nvPr>
+        </p:nvSpPr>
+        <p:spPr/>
+        <p:txBody>
+          <a:bodyPr/>
+          <a:lstStyle/>
+          <a:p>
+            <a:fld id="{2D8B709C-82E0-4ADF-BDA3-CCA1C8B22229}" type="slidenum">
+              <a:rPr lang="en-US" smtClean="0"/>
+              <a:t>24</a:t>
+            </a:fld>
+            <a:endParaRPr lang="en-US"/>
+          </a:p>
+        </p:txBody>
+      </p:sp>
+    </p:spTree>
+    <p:extLst>
+      <p:ext uri="{BB962C8B-B14F-4D97-AF65-F5344CB8AC3E}">
+        <p14:creationId xmlns:p14="http://schemas.microsoft.com/office/powerpoint/2010/main" val="2269376692"/>
+      </p:ext>
+    </p:extLst>
+  </p:cSld>
+  <p:clrMapOvr>
+    <a:masterClrMapping/>
+  </p:clrMapOvr>
+</p:notes>
+</file>
+
 <file path=ppt/notesSlides/notesSlide2.xml><?xml version="1.0" encoding="utf-8"?>
 <p:notes xmlns:a="http://schemas.openxmlformats.org/drawingml/2006/main" xmlns:r="http://schemas.openxmlformats.org/officeDocument/2006/relationships" xmlns:p="http://schemas.openxmlformats.org/presentationml/2006/main">
   <p:cSld>
@@ -1175,17 +1480,11 @@
 </file>
 
 <file path=ppt/notesSlides/notesSlide7.xml><?xml version="1.0" encoding="utf-8"?>
-<p:notes xmlns:a="http://schemas.openxmlformats.org/drawingml/2006/main" xmlns:r="http://schemas.openxmlformats.org/officeDocument/2006/relationships" xmlns:p="http://schemas.openxmlformats.org/presentationml/2006/main">
+<p:notes xmlns:a="http://schemas.openxmlformats.org/drawingml/2006/main" xmlns:r="http://schemas.openxmlformats.org/officeDocument/2006/relationships" xmlns:p="http://schemas.openxmlformats.org/presentationml/2006/main" showMasterSp="0" showMasterPhAnim="0">
   <p:cSld>
     <p:spTree>
       <p:nvGrpSpPr>
-        <p:cNvPr id="1" name="">
-          <a:extLst>
-            <a:ext uri="{FF2B5EF4-FFF2-40B4-BE49-F238E27FC236}">
-              <a16:creationId xmlns:a16="http://schemas.microsoft.com/office/drawing/2014/main" id="{2E9E1876-9A88-AC9A-EEA0-09A5D443F787}"/>
-            </a:ext>
-          </a:extLst>
-        </p:cNvPr>
+        <p:cNvPr id="1" name="Shape 55"/>
         <p:cNvGrpSpPr/>
         <p:nvPr/>
       </p:nvGrpSpPr>
@@ -1199,18 +1498,12 @@
       </p:grpSpPr>
       <p:sp>
         <p:nvSpPr>
-          <p:cNvPr id="2" name="Slide Image Placeholder 1">
-            <a:extLst>
-              <a:ext uri="{FF2B5EF4-FFF2-40B4-BE49-F238E27FC236}">
-                <a16:creationId xmlns:a16="http://schemas.microsoft.com/office/drawing/2014/main" id="{8A48ED5F-1EBB-D3DA-21D1-17A4AC27EB0B}"/>
-              </a:ext>
-            </a:extLst>
-          </p:cNvPr>
+          <p:cNvPr id="56" name="Google Shape;56;g37105969b97_0_0:notes"/>
           <p:cNvSpPr>
             <a:spLocks noGrp="1" noRot="1" noChangeAspect="1"/>
           </p:cNvSpPr>
           <p:nvPr>
-            <p:ph type="sldImg"/>
+            <p:ph type="sldImg" idx="2"/>
           </p:nvPr>
         </p:nvSpPr>
         <p:spPr>
@@ -1218,68 +1511,71 @@
             <a:off x="381000" y="685800"/>
             <a:ext cx="6096000" cy="3429000"/>
           </a:xfrm>
-        </p:spPr>
-      </p:sp>
-      <p:sp>
-        <p:nvSpPr>
-          <p:cNvPr id="3" name="Notes Placeholder 2">
-            <a:extLst>
-              <a:ext uri="{FF2B5EF4-FFF2-40B4-BE49-F238E27FC236}">
-                <a16:creationId xmlns:a16="http://schemas.microsoft.com/office/drawing/2014/main" id="{BDD7F1C4-8BD1-42DE-2251-2E35849A0D89}"/>
-              </a:ext>
-            </a:extLst>
-          </p:cNvPr>
-          <p:cNvSpPr>
+          <a:custGeom>
+            <a:avLst/>
+            <a:gdLst/>
+            <a:ahLst/>
+            <a:cxnLst/>
+            <a:rect l="l" t="t" r="r" b="b"/>
+            <a:pathLst>
+              <a:path w="120000" h="120000" extrusionOk="0">
+                <a:moveTo>
+                  <a:pt x="0" y="0"/>
+                </a:moveTo>
+                <a:lnTo>
+                  <a:pt x="120000" y="0"/>
+                </a:lnTo>
+                <a:lnTo>
+                  <a:pt x="120000" y="120000"/>
+                </a:lnTo>
+                <a:lnTo>
+                  <a:pt x="0" y="120000"/>
+                </a:lnTo>
+                <a:close/>
+              </a:path>
+            </a:pathLst>
+          </a:custGeom>
+        </p:spPr>
+      </p:sp>
+      <p:sp>
+        <p:nvSpPr>
+          <p:cNvPr id="57" name="Google Shape;57;g37105969b97_0_0:notes"/>
+          <p:cNvSpPr txBox="1">
             <a:spLocks noGrp="1"/>
           </p:cNvSpPr>
           <p:nvPr>
             <p:ph type="body" idx="1"/>
           </p:nvPr>
         </p:nvSpPr>
-        <p:spPr/>
-        <p:txBody>
-          <a:bodyPr/>
+        <p:spPr>
+          <a:xfrm>
+            <a:off x="685800" y="4343400"/>
+            <a:ext cx="5486400" cy="4114800"/>
+          </a:xfrm>
+          <a:prstGeom prst="rect">
+            <a:avLst/>
+          </a:prstGeom>
+        </p:spPr>
+        <p:txBody>
+          <a:bodyPr spcFirstLastPara="1" wrap="square" lIns="91425" tIns="91425" rIns="91425" bIns="91425" anchor="t" anchorCtr="0">
+            <a:noAutofit/>
+          </a:bodyPr>
           <a:lstStyle/>
           <a:p>
-            <a:endParaRPr lang="en-US" dirty="0"/>
-          </a:p>
-        </p:txBody>
-      </p:sp>
-      <p:sp>
-        <p:nvSpPr>
-          <p:cNvPr id="4" name="Slide Number Placeholder 3">
-            <a:extLst>
-              <a:ext uri="{FF2B5EF4-FFF2-40B4-BE49-F238E27FC236}">
-                <a16:creationId xmlns:a16="http://schemas.microsoft.com/office/drawing/2014/main" id="{0E78741C-CD8D-4A35-2F6E-59CC0DFE77A8}"/>
-              </a:ext>
-            </a:extLst>
-          </p:cNvPr>
-          <p:cNvSpPr>
-            <a:spLocks noGrp="1"/>
-          </p:cNvSpPr>
-          <p:nvPr>
-            <p:ph type="sldNum" sz="quarter" idx="5"/>
-          </p:nvPr>
-        </p:nvSpPr>
-        <p:spPr/>
-        <p:txBody>
-          <a:bodyPr/>
-          <a:lstStyle/>
-          <a:p>
-            <a:fld id="{292570D5-C374-43AE-876B-55C2A221664E}" type="slidenum">
-              <a:rPr lang="en-US" smtClean="0"/>
-              <a:t>7</a:t>
-            </a:fld>
-            <a:endParaRPr lang="en-US"/>
+            <a:pPr marL="0" lvl="0" indent="0" algn="l" rtl="0">
+              <a:spcBef>
+                <a:spcPts val="0"/>
+              </a:spcBef>
+              <a:spcAft>
+                <a:spcPts val="0"/>
+              </a:spcAft>
+              <a:buNone/>
+            </a:pPr>
+            <a:endParaRPr/>
           </a:p>
         </p:txBody>
       </p:sp>
     </p:spTree>
-    <p:extLst>
-      <p:ext uri="{BB962C8B-B14F-4D97-AF65-F5344CB8AC3E}">
-        <p14:creationId xmlns:p14="http://schemas.microsoft.com/office/powerpoint/2010/main" val="1313543551"/>
-      </p:ext>
-    </p:extLst>
   </p:cSld>
   <p:clrMapOvr>
     <a:masterClrMapping/>
@@ -1288,11 +1584,11 @@
 </file>
 
 <file path=ppt/notesSlides/notesSlide8.xml><?xml version="1.0" encoding="utf-8"?>
-<p:notes xmlns:a="http://schemas.openxmlformats.org/drawingml/2006/main" xmlns:r="http://schemas.openxmlformats.org/officeDocument/2006/relationships" xmlns:p="http://schemas.openxmlformats.org/presentationml/2006/main">
+<p:notes xmlns:a="http://schemas.openxmlformats.org/drawingml/2006/main" xmlns:r="http://schemas.openxmlformats.org/officeDocument/2006/relationships" xmlns:p="http://schemas.openxmlformats.org/presentationml/2006/main" showMasterSp="0" showMasterPhAnim="0">
   <p:cSld>
     <p:spTree>
       <p:nvGrpSpPr>
-        <p:cNvPr id="1" name=""/>
+        <p:cNvPr id="1" name="Shape 60"/>
         <p:cNvGrpSpPr/>
         <p:nvPr/>
       </p:nvGrpSpPr>
@@ -1306,64 +1602,188 @@
       </p:grpSpPr>
       <p:sp>
         <p:nvSpPr>
-          <p:cNvPr id="2" name="Slide Image Placeholder 1"/>
+          <p:cNvPr id="61" name="Google Shape;61;g3715ed335dd_0_0:notes"/>
           <p:cNvSpPr>
             <a:spLocks noGrp="1" noRot="1" noChangeAspect="1"/>
           </p:cNvSpPr>
           <p:nvPr>
-            <p:ph type="sldImg"/>
+            <p:ph type="sldImg" idx="2"/>
           </p:nvPr>
         </p:nvSpPr>
-        <p:spPr/>
-      </p:sp>
-      <p:sp>
-        <p:nvSpPr>
-          <p:cNvPr id="3" name="Notes Placeholder 2"/>
-          <p:cNvSpPr>
+        <p:spPr>
+          <a:xfrm>
+            <a:off x="381000" y="685800"/>
+            <a:ext cx="6096000" cy="3429000"/>
+          </a:xfrm>
+          <a:custGeom>
+            <a:avLst/>
+            <a:gdLst/>
+            <a:ahLst/>
+            <a:cxnLst/>
+            <a:rect l="l" t="t" r="r" b="b"/>
+            <a:pathLst>
+              <a:path w="120000" h="120000" extrusionOk="0">
+                <a:moveTo>
+                  <a:pt x="0" y="0"/>
+                </a:moveTo>
+                <a:lnTo>
+                  <a:pt x="120000" y="0"/>
+                </a:lnTo>
+                <a:lnTo>
+                  <a:pt x="120000" y="120000"/>
+                </a:lnTo>
+                <a:lnTo>
+                  <a:pt x="0" y="120000"/>
+                </a:lnTo>
+                <a:close/>
+              </a:path>
+            </a:pathLst>
+          </a:custGeom>
+        </p:spPr>
+      </p:sp>
+      <p:sp>
+        <p:nvSpPr>
+          <p:cNvPr id="62" name="Google Shape;62;g3715ed335dd_0_0:notes"/>
+          <p:cNvSpPr txBox="1">
             <a:spLocks noGrp="1"/>
           </p:cNvSpPr>
           <p:nvPr>
             <p:ph type="body" idx="1"/>
           </p:nvPr>
         </p:nvSpPr>
-        <p:spPr/>
-        <p:txBody>
-          <a:bodyPr/>
+        <p:spPr>
+          <a:xfrm>
+            <a:off x="685800" y="4343400"/>
+            <a:ext cx="5486400" cy="4114800"/>
+          </a:xfrm>
+          <a:prstGeom prst="rect">
+            <a:avLst/>
+          </a:prstGeom>
+        </p:spPr>
+        <p:txBody>
+          <a:bodyPr spcFirstLastPara="1" wrap="square" lIns="91425" tIns="91425" rIns="91425" bIns="91425" anchor="t" anchorCtr="0">
+            <a:noAutofit/>
+          </a:bodyPr>
           <a:lstStyle/>
           <a:p>
-            <a:endParaRPr lang="en-US" dirty="0"/>
-          </a:p>
-        </p:txBody>
-      </p:sp>
-      <p:sp>
-        <p:nvSpPr>
-          <p:cNvPr id="4" name="Slide Number Placeholder 3"/>
+            <a:pPr marL="0" lvl="0" indent="0" algn="l" rtl="0">
+              <a:spcBef>
+                <a:spcPts val="0"/>
+              </a:spcBef>
+              <a:spcAft>
+                <a:spcPts val="0"/>
+              </a:spcAft>
+              <a:buNone/>
+            </a:pPr>
+            <a:endParaRPr/>
+          </a:p>
+        </p:txBody>
+      </p:sp>
+    </p:spTree>
+  </p:cSld>
+  <p:clrMapOvr>
+    <a:masterClrMapping/>
+  </p:clrMapOvr>
+</p:notes>
+</file>
+
+<file path=ppt/notesSlides/notesSlide9.xml><?xml version="1.0" encoding="utf-8"?>
+<p:notes xmlns:a="http://schemas.openxmlformats.org/drawingml/2006/main" xmlns:r="http://schemas.openxmlformats.org/officeDocument/2006/relationships" xmlns:p="http://schemas.openxmlformats.org/presentationml/2006/main" showMasterSp="0" showMasterPhAnim="0">
+  <p:cSld>
+    <p:spTree>
+      <p:nvGrpSpPr>
+        <p:cNvPr id="1" name="Shape 66"/>
+        <p:cNvGrpSpPr/>
+        <p:nvPr/>
+      </p:nvGrpSpPr>
+      <p:grpSpPr>
+        <a:xfrm>
+          <a:off x="0" y="0"/>
+          <a:ext cx="0" cy="0"/>
+          <a:chOff x="0" y="0"/>
+          <a:chExt cx="0" cy="0"/>
+        </a:xfrm>
+      </p:grpSpPr>
+      <p:sp>
+        <p:nvSpPr>
+          <p:cNvPr id="67" name="Google Shape;67;g37105969b97_1_0:notes"/>
           <p:cNvSpPr>
+            <a:spLocks noGrp="1" noRot="1" noChangeAspect="1"/>
+          </p:cNvSpPr>
+          <p:nvPr>
+            <p:ph type="sldImg" idx="2"/>
+          </p:nvPr>
+        </p:nvSpPr>
+        <p:spPr>
+          <a:xfrm>
+            <a:off x="381000" y="685800"/>
+            <a:ext cx="6096000" cy="3429000"/>
+          </a:xfrm>
+          <a:custGeom>
+            <a:avLst/>
+            <a:gdLst/>
+            <a:ahLst/>
+            <a:cxnLst/>
+            <a:rect l="l" t="t" r="r" b="b"/>
+            <a:pathLst>
+              <a:path w="120000" h="120000" extrusionOk="0">
+                <a:moveTo>
+                  <a:pt x="0" y="0"/>
+                </a:moveTo>
+                <a:lnTo>
+                  <a:pt x="120000" y="0"/>
+                </a:lnTo>
+                <a:lnTo>
+                  <a:pt x="120000" y="120000"/>
+                </a:lnTo>
+                <a:lnTo>
+                  <a:pt x="0" y="120000"/>
+                </a:lnTo>
+                <a:close/>
+              </a:path>
+            </a:pathLst>
+          </a:custGeom>
+        </p:spPr>
+      </p:sp>
+      <p:sp>
+        <p:nvSpPr>
+          <p:cNvPr id="68" name="Google Shape;68;g37105969b97_1_0:notes"/>
+          <p:cNvSpPr txBox="1">
             <a:spLocks noGrp="1"/>
           </p:cNvSpPr>
           <p:nvPr>
-            <p:ph type="sldNum" sz="quarter" idx="5"/>
+            <p:ph type="body" idx="1"/>
           </p:nvPr>
         </p:nvSpPr>
-        <p:spPr/>
-        <p:txBody>
-          <a:bodyPr/>
+        <p:spPr>
+          <a:xfrm>
+            <a:off x="685800" y="4343400"/>
+            <a:ext cx="5486400" cy="4114800"/>
+          </a:xfrm>
+          <a:prstGeom prst="rect">
+            <a:avLst/>
+          </a:prstGeom>
+        </p:spPr>
+        <p:txBody>
+          <a:bodyPr spcFirstLastPara="1" wrap="square" lIns="91425" tIns="91425" rIns="91425" bIns="91425" anchor="t" anchorCtr="0">
+            <a:noAutofit/>
+          </a:bodyPr>
           <a:lstStyle/>
           <a:p>
-            <a:fld id="{2D8B709C-82E0-4ADF-BDA3-CCA1C8B22229}" type="slidenum">
-              <a:rPr lang="en-US" smtClean="0"/>
-              <a:t>20</a:t>
-            </a:fld>
-            <a:endParaRPr lang="en-US"/>
+            <a:pPr marL="0" lvl="0" indent="0" algn="l" rtl="0">
+              <a:spcBef>
+                <a:spcPts val="0"/>
+              </a:spcBef>
+              <a:spcAft>
+                <a:spcPts val="0"/>
+              </a:spcAft>
+              <a:buNone/>
+            </a:pPr>
+            <a:endParaRPr/>
           </a:p>
         </p:txBody>
       </p:sp>
     </p:spTree>
-    <p:extLst>
-      <p:ext uri="{BB962C8B-B14F-4D97-AF65-F5344CB8AC3E}">
-        <p14:creationId xmlns:p14="http://schemas.microsoft.com/office/powerpoint/2010/main" val="2269376692"/>
-      </p:ext>
-    </p:extLst>
   </p:cSld>
   <p:clrMapOvr>
     <a:masterClrMapping/>
@@ -1427,7 +1847,7 @@
           <a:p>
             <a:fld id="{971AFA9C-17DA-4726-B9E3-ADECF7729AF7}" type="datetimeFigureOut">
               <a:rPr lang="en-US" smtClean="0"/>
-              <a:t>6/19/2026</a:t>
+              <a:t>6/22/2026</a:t>
             </a:fld>
             <a:endParaRPr lang="en-US"/>
           </a:p>
@@ -4047,7 +4467,7 @@
           <a:p>
             <a:fld id="{971AFA9C-17DA-4726-B9E3-ADECF7729AF7}" type="datetimeFigureOut">
               <a:rPr lang="en-US" smtClean="0"/>
-              <a:t>6/19/2026</a:t>
+              <a:t>6/22/2026</a:t>
             </a:fld>
             <a:endParaRPr lang="en-US"/>
           </a:p>
@@ -5791,7 +6211,7 @@
           <a:p>
             <a:fld id="{971AFA9C-17DA-4726-B9E3-ADECF7729AF7}" type="datetimeFigureOut">
               <a:rPr lang="en-US" smtClean="0"/>
-              <a:t>6/19/2026</a:t>
+              <a:t>6/22/2026</a:t>
             </a:fld>
             <a:endParaRPr lang="en-US"/>
           </a:p>
@@ -7635,7 +8055,7 @@
           <a:p>
             <a:fld id="{971AFA9C-17DA-4726-B9E3-ADECF7729AF7}" type="datetimeFigureOut">
               <a:rPr lang="en-US" smtClean="0"/>
-              <a:t>6/19/2026</a:t>
+              <a:t>6/22/2026</a:t>
             </a:fld>
             <a:endParaRPr lang="en-US"/>
           </a:p>
@@ -7840,7 +8260,7 @@
           <a:p>
             <a:fld id="{971AFA9C-17DA-4726-B9E3-ADECF7729AF7}" type="datetimeFigureOut">
               <a:rPr lang="en-US" smtClean="0"/>
-              <a:t>6/19/2026</a:t>
+              <a:t>6/22/2026</a:t>
             </a:fld>
             <a:endParaRPr lang="en-US"/>
           </a:p>
@@ -8088,7 +8508,7 @@
           <a:p>
             <a:fld id="{971AFA9C-17DA-4726-B9E3-ADECF7729AF7}" type="datetimeFigureOut">
               <a:rPr lang="en-US" smtClean="0"/>
-              <a:t>6/19/2026</a:t>
+              <a:t>6/22/2026</a:t>
             </a:fld>
             <a:endParaRPr lang="en-US"/>
           </a:p>
@@ -8405,7 +8825,7 @@
           <a:p>
             <a:fld id="{971AFA9C-17DA-4726-B9E3-ADECF7729AF7}" type="datetimeFigureOut">
               <a:rPr lang="en-US" smtClean="0"/>
-              <a:t>6/19/2026</a:t>
+              <a:t>6/22/2026</a:t>
             </a:fld>
             <a:endParaRPr lang="en-US"/>
           </a:p>
@@ -9058,7 +9478,7 @@
           <a:p>
             <a:fld id="{971AFA9C-17DA-4726-B9E3-ADECF7729AF7}" type="datetimeFigureOut">
               <a:rPr lang="en-US" smtClean="0"/>
-              <a:t>6/19/2026</a:t>
+              <a:t>6/22/2026</a:t>
             </a:fld>
             <a:endParaRPr lang="en-US"/>
           </a:p>
@@ -9968,7 +10388,7 @@
           <a:p>
             <a:fld id="{971AFA9C-17DA-4726-B9E3-ADECF7729AF7}" type="datetimeFigureOut">
               <a:rPr lang="en-US" smtClean="0"/>
-              <a:t>6/19/2026</a:t>
+              <a:t>6/22/2026</a:t>
             </a:fld>
             <a:endParaRPr lang="en-US"/>
           </a:p>
@@ -11130,7 +11550,7 @@
           <a:p>
             <a:fld id="{971AFA9C-17DA-4726-B9E3-ADECF7729AF7}" type="datetimeFigureOut">
               <a:rPr lang="en-US" smtClean="0"/>
-              <a:t>6/19/2026</a:t>
+              <a:t>6/22/2026</a:t>
             </a:fld>
             <a:endParaRPr lang="en-US"/>
           </a:p>
@@ -11440,7 +11860,7 @@
           <a:p>
             <a:fld id="{971AFA9C-17DA-4726-B9E3-ADECF7729AF7}" type="datetimeFigureOut">
               <a:rPr lang="en-US" smtClean="0"/>
-              <a:t>6/19/2026</a:t>
+              <a:t>6/22/2026</a:t>
             </a:fld>
             <a:endParaRPr lang="en-US"/>
           </a:p>
@@ -11712,7 +12132,7 @@
           <a:p>
             <a:fld id="{971AFA9C-17DA-4726-B9E3-ADECF7729AF7}" type="datetimeFigureOut">
               <a:rPr lang="en-US" smtClean="0"/>
-              <a:t>6/19/2026</a:t>
+              <a:t>6/22/2026</a:t>
             </a:fld>
             <a:endParaRPr lang="en-US"/>
           </a:p>
@@ -13527,7 +13947,7 @@
           <a:p>
             <a:fld id="{971AFA9C-17DA-4726-B9E3-ADECF7729AF7}" type="datetimeFigureOut">
               <a:rPr lang="en-US" smtClean="0"/>
-              <a:t>6/19/2026</a:t>
+              <a:t>6/22/2026</a:t>
             </a:fld>
             <a:endParaRPr lang="en-US"/>
           </a:p>
@@ -13861,7 +14281,7 @@
           <a:p>
             <a:fld id="{971AFA9C-17DA-4726-B9E3-ADECF7729AF7}" type="datetimeFigureOut">
               <a:rPr lang="en-US" smtClean="0"/>
-              <a:t>6/19/2026</a:t>
+              <a:t>6/22/2026</a:t>
             </a:fld>
             <a:endParaRPr lang="en-US"/>
           </a:p>
@@ -14161,7 +14581,7 @@
           <a:p>
             <a:fld id="{971AFA9C-17DA-4726-B9E3-ADECF7729AF7}" type="datetimeFigureOut">
               <a:rPr lang="en-US" smtClean="0"/>
-              <a:t>6/19/2026</a:t>
+              <a:t>6/22/2026</a:t>
             </a:fld>
             <a:endParaRPr lang="en-US"/>
           </a:p>
@@ -14461,7 +14881,7 @@
           <a:p>
             <a:fld id="{971AFA9C-17DA-4726-B9E3-ADECF7729AF7}" type="datetimeFigureOut">
               <a:rPr lang="en-US" smtClean="0"/>
-              <a:t>6/19/2026</a:t>
+              <a:t>6/22/2026</a:t>
             </a:fld>
             <a:endParaRPr lang="en-US"/>
           </a:p>
@@ -15003,7 +15423,7 @@
           <a:p>
             <a:fld id="{971AFA9C-17DA-4726-B9E3-ADECF7729AF7}" type="datetimeFigureOut">
               <a:rPr lang="en-US" smtClean="0"/>
-              <a:t>6/19/2026</a:t>
+              <a:t>6/22/2026</a:t>
             </a:fld>
             <a:endParaRPr lang="en-US"/>
           </a:p>
@@ -15153,7 +15573,7 @@
           <a:p>
             <a:fld id="{971AFA9C-17DA-4726-B9E3-ADECF7729AF7}" type="datetimeFigureOut">
               <a:rPr lang="en-US" smtClean="0"/>
-              <a:t>6/19/2026</a:t>
+              <a:t>6/22/2026</a:t>
             </a:fld>
             <a:endParaRPr lang="en-US"/>
           </a:p>
@@ -15311,7 +15731,7 @@
           <a:p>
             <a:fld id="{971AFA9C-17DA-4726-B9E3-ADECF7729AF7}" type="datetimeFigureOut">
               <a:rPr lang="en-US" smtClean="0"/>
-              <a:t>6/19/2026</a:t>
+              <a:t>6/22/2026</a:t>
             </a:fld>
             <a:endParaRPr lang="en-US"/>
           </a:p>
@@ -15578,7 +15998,7 @@
           <a:p>
             <a:fld id="{971AFA9C-17DA-4726-B9E3-ADECF7729AF7}" type="datetimeFigureOut">
               <a:rPr lang="en-US" smtClean="0"/>
-              <a:t>6/19/2026</a:t>
+              <a:t>6/22/2026</a:t>
             </a:fld>
             <a:endParaRPr lang="en-US"/>
           </a:p>
@@ -15706,7 +16126,7 @@
           <a:p>
             <a:fld id="{971AFA9C-17DA-4726-B9E3-ADECF7729AF7}" type="datetimeFigureOut">
               <a:rPr lang="en-US" smtClean="0"/>
-              <a:t>6/19/2026</a:t>
+              <a:t>6/22/2026</a:t>
             </a:fld>
             <a:endParaRPr lang="en-US"/>
           </a:p>
@@ -16141,7 +16561,7 @@
           <a:p>
             <a:fld id="{971AFA9C-17DA-4726-B9E3-ADECF7729AF7}" type="datetimeFigureOut">
               <a:rPr lang="en-US" smtClean="0"/>
-              <a:t>6/19/2026</a:t>
+              <a:t>6/22/2026</a:t>
             </a:fld>
             <a:endParaRPr lang="en-US"/>
           </a:p>
@@ -16288,7 +16708,7 @@
           <a:p>
             <a:fld id="{971AFA9C-17DA-4726-B9E3-ADECF7729AF7}" type="datetimeFigureOut">
               <a:rPr lang="en-US" smtClean="0"/>
-              <a:t>6/19/2026</a:t>
+              <a:t>6/22/2026</a:t>
             </a:fld>
             <a:endParaRPr lang="en-US"/>
           </a:p>
@@ -18218,7 +18638,7 @@
           <a:p>
             <a:fld id="{971AFA9C-17DA-4726-B9E3-ADECF7729AF7}" type="datetimeFigureOut">
               <a:rPr lang="en-US" smtClean="0"/>
-              <a:t>6/19/2026</a:t>
+              <a:t>6/22/2026</a:t>
             </a:fld>
             <a:endParaRPr lang="en-US"/>
           </a:p>
@@ -18554,7 +18974,7 @@
           <a:p>
             <a:fld id="{971AFA9C-17DA-4726-B9E3-ADECF7729AF7}" type="datetimeFigureOut">
               <a:rPr lang="en-US" smtClean="0"/>
-              <a:t>6/19/2026</a:t>
+              <a:t>6/22/2026</a:t>
             </a:fld>
             <a:endParaRPr lang="en-US"/>
           </a:p>
@@ -18849,7 +19269,7 @@
           <a:p>
             <a:fld id="{971AFA9C-17DA-4726-B9E3-ADECF7729AF7}" type="datetimeFigureOut">
               <a:rPr lang="en-US" smtClean="0"/>
-              <a:t>6/19/2026</a:t>
+              <a:t>6/22/2026</a:t>
             </a:fld>
             <a:endParaRPr lang="en-US"/>
           </a:p>
@@ -18978,7 +19398,7 @@
           <a:p>
             <a:fld id="{971AFA9C-17DA-4726-B9E3-ADECF7729AF7}" type="datetimeFigureOut">
               <a:rPr lang="en-US" smtClean="0"/>
-              <a:t>6/19/2026</a:t>
+              <a:t>6/22/2026</a:t>
             </a:fld>
             <a:endParaRPr lang="en-US"/>
           </a:p>
@@ -20773,7 +21193,7 @@
           <a:p>
             <a:fld id="{971AFA9C-17DA-4726-B9E3-ADECF7729AF7}" type="datetimeFigureOut">
               <a:rPr lang="en-US" smtClean="0"/>
-              <a:t>6/19/2026</a:t>
+              <a:t>6/22/2026</a:t>
             </a:fld>
             <a:endParaRPr lang="en-US"/>
           </a:p>
@@ -22339,7 +22759,7 @@
           <a:p>
             <a:fld id="{971AFA9C-17DA-4726-B9E3-ADECF7729AF7}" type="datetimeFigureOut">
               <a:rPr lang="en-US" smtClean="0"/>
-              <a:t>6/19/2026</a:t>
+              <a:t>6/22/2026</a:t>
             </a:fld>
             <a:endParaRPr lang="en-US"/>
           </a:p>
@@ -24146,7 +24566,7 @@
           <a:p>
             <a:fld id="{971AFA9C-17DA-4726-B9E3-ADECF7729AF7}" type="datetimeFigureOut">
               <a:rPr lang="en-US" smtClean="0"/>
-              <a:t>6/19/2026</a:t>
+              <a:t>6/22/2026</a:t>
             </a:fld>
             <a:endParaRPr lang="en-US"/>
           </a:p>
@@ -24395,7 +24815,7 @@
           <a:p>
             <a:fld id="{971AFA9C-17DA-4726-B9E3-ADECF7729AF7}" type="datetimeFigureOut">
               <a:rPr lang="en-US" smtClean="0"/>
-              <a:t>6/19/2026</a:t>
+              <a:t>6/22/2026</a:t>
             </a:fld>
             <a:endParaRPr lang="en-US"/>
           </a:p>
@@ -24701,7 +25121,7 @@
           <a:p>
             <a:fld id="{971AFA9C-17DA-4726-B9E3-ADECF7729AF7}" type="datetimeFigureOut">
               <a:rPr lang="en-US" smtClean="0"/>
-              <a:t>6/19/2026</a:t>
+              <a:t>6/22/2026</a:t>
             </a:fld>
             <a:endParaRPr lang="en-US"/>
           </a:p>
@@ -24902,7 +25322,7 @@
           <a:p>
             <a:fld id="{971AFA9C-17DA-4726-B9E3-ADECF7729AF7}" type="datetimeFigureOut">
               <a:rPr lang="en-US" smtClean="0"/>
-              <a:t>6/19/2026</a:t>
+              <a:t>6/22/2026</a:t>
             </a:fld>
             <a:endParaRPr lang="en-US"/>
           </a:p>
@@ -25390,7 +25810,7 @@
           <a:p>
             <a:fld id="{971AFA9C-17DA-4726-B9E3-ADECF7729AF7}" type="datetimeFigureOut">
               <a:rPr lang="en-US" smtClean="0"/>
-              <a:t>6/19/2026</a:t>
+              <a:t>6/22/2026</a:t>
             </a:fld>
             <a:endParaRPr lang="en-US"/>
           </a:p>
@@ -26026,7 +26446,7 @@
           <a:p>
             <a:fld id="{971AFA9C-17DA-4726-B9E3-ADECF7729AF7}" type="datetimeFigureOut">
               <a:rPr lang="en-US" smtClean="0"/>
-              <a:t>6/19/2026</a:t>
+              <a:t>6/22/2026</a:t>
             </a:fld>
             <a:endParaRPr lang="en-US"/>
           </a:p>
@@ -27083,7 +27503,7 @@
           <a:p>
             <a:fld id="{971AFA9C-17DA-4726-B9E3-ADECF7729AF7}" type="datetimeFigureOut">
               <a:rPr lang="en-US" smtClean="0"/>
-              <a:t>6/19/2026</a:t>
+              <a:t>6/22/2026</a:t>
             </a:fld>
             <a:endParaRPr lang="en-US"/>
           </a:p>
@@ -28119,7 +28539,7 @@
           <a:p>
             <a:fld id="{971AFA9C-17DA-4726-B9E3-ADECF7729AF7}" type="datetimeFigureOut">
               <a:rPr lang="en-US" smtClean="0"/>
-              <a:t>6/19/2026</a:t>
+              <a:t>6/22/2026</a:t>
             </a:fld>
             <a:endParaRPr lang="en-US"/>
           </a:p>
@@ -29815,7 +30235,7 @@
           <a:p>
             <a:fld id="{971AFA9C-17DA-4726-B9E3-ADECF7729AF7}" type="datetimeFigureOut">
               <a:rPr lang="en-US" smtClean="0"/>
-              <a:t>6/19/2026</a:t>
+              <a:t>6/22/2026</a:t>
             </a:fld>
             <a:endParaRPr lang="en-US"/>
           </a:p>
@@ -31618,7 +32038,7 @@
           <a:p>
             <a:fld id="{971AFA9C-17DA-4726-B9E3-ADECF7729AF7}" type="datetimeFigureOut">
               <a:rPr lang="en-US" smtClean="0"/>
-              <a:t>6/19/2026</a:t>
+              <a:t>6/22/2026</a:t>
             </a:fld>
             <a:endParaRPr lang="en-US"/>
           </a:p>
@@ -31796,7 +32216,7 @@
           <a:p>
             <a:fld id="{971AFA9C-17DA-4726-B9E3-ADECF7729AF7}" type="datetimeFigureOut">
               <a:rPr lang="en-US" smtClean="0"/>
-              <a:t>6/19/2026</a:t>
+              <a:t>6/22/2026</a:t>
             </a:fld>
             <a:endParaRPr lang="en-US"/>
           </a:p>
@@ -32022,7 +32442,7 @@
           <a:p>
             <a:fld id="{971AFA9C-17DA-4726-B9E3-ADECF7729AF7}" type="datetimeFigureOut">
               <a:rPr lang="en-US" smtClean="0"/>
-              <a:t>6/19/2026</a:t>
+              <a:t>6/22/2026</a:t>
             </a:fld>
             <a:endParaRPr lang="en-US"/>
           </a:p>
@@ -32311,7 +32731,7 @@
           <a:p>
             <a:fld id="{971AFA9C-17DA-4726-B9E3-ADECF7729AF7}" type="datetimeFigureOut">
               <a:rPr lang="en-US" smtClean="0"/>
-              <a:t>6/19/2026</a:t>
+              <a:t>6/22/2026</a:t>
             </a:fld>
             <a:endParaRPr lang="en-US"/>
           </a:p>
@@ -32922,7 +33342,7 @@
           <a:p>
             <a:fld id="{971AFA9C-17DA-4726-B9E3-ADECF7729AF7}" type="datetimeFigureOut">
               <a:rPr lang="en-US" smtClean="0"/>
-              <a:t>6/19/2026</a:t>
+              <a:t>6/22/2026</a:t>
             </a:fld>
             <a:endParaRPr lang="en-US"/>
           </a:p>
@@ -33198,7 +33618,7 @@
           <a:p>
             <a:fld id="{971AFA9C-17DA-4726-B9E3-ADECF7729AF7}" type="datetimeFigureOut">
               <a:rPr lang="en-US" smtClean="0"/>
-              <a:t>6/19/2026</a:t>
+              <a:t>6/22/2026</a:t>
             </a:fld>
             <a:endParaRPr lang="en-US"/>
           </a:p>
@@ -34055,7 +34475,7 @@
           <a:p>
             <a:fld id="{971AFA9C-17DA-4726-B9E3-ADECF7729AF7}" type="datetimeFigureOut">
               <a:rPr lang="en-US" smtClean="0"/>
-              <a:t>6/19/2026</a:t>
+              <a:t>6/22/2026</a:t>
             </a:fld>
             <a:endParaRPr lang="en-US"/>
           </a:p>
@@ -35157,7 +35577,7 @@
           <a:p>
             <a:fld id="{971AFA9C-17DA-4726-B9E3-ADECF7729AF7}" type="datetimeFigureOut">
               <a:rPr lang="en-US" smtClean="0"/>
-              <a:t>6/19/2026</a:t>
+              <a:t>6/22/2026</a:t>
             </a:fld>
             <a:endParaRPr lang="en-US"/>
           </a:p>
@@ -35445,7 +35865,7 @@
           <a:p>
             <a:fld id="{971AFA9C-17DA-4726-B9E3-ADECF7729AF7}" type="datetimeFigureOut">
               <a:rPr lang="en-US" smtClean="0"/>
-              <a:t>6/19/2026</a:t>
+              <a:t>6/22/2026</a:t>
             </a:fld>
             <a:endParaRPr lang="en-US"/>
           </a:p>
@@ -35918,7 +36338,7 @@
           <a:p>
             <a:fld id="{971AFA9C-17DA-4726-B9E3-ADECF7729AF7}" type="datetimeFigureOut">
               <a:rPr lang="en-US" smtClean="0"/>
-              <a:t>6/19/2026</a:t>
+              <a:t>6/22/2026</a:t>
             </a:fld>
             <a:endParaRPr lang="en-US"/>
           </a:p>
@@ -36230,7 +36650,7 @@
           <a:p>
             <a:fld id="{971AFA9C-17DA-4726-B9E3-ADECF7729AF7}" type="datetimeFigureOut">
               <a:rPr lang="en-US" smtClean="0"/>
-              <a:t>6/19/2026</a:t>
+              <a:t>6/22/2026</a:t>
             </a:fld>
             <a:endParaRPr lang="en-US"/>
           </a:p>
@@ -36508,7 +36928,7 @@
           <a:p>
             <a:fld id="{971AFA9C-17DA-4726-B9E3-ADECF7729AF7}" type="datetimeFigureOut">
               <a:rPr lang="en-US" smtClean="0"/>
-              <a:t>6/19/2026</a:t>
+              <a:t>6/22/2026</a:t>
             </a:fld>
             <a:endParaRPr lang="en-US"/>
           </a:p>
@@ -36786,7 +37206,7 @@
           <a:p>
             <a:fld id="{971AFA9C-17DA-4726-B9E3-ADECF7729AF7}" type="datetimeFigureOut">
               <a:rPr lang="en-US" smtClean="0"/>
-              <a:t>6/19/2026</a:t>
+              <a:t>6/22/2026</a:t>
             </a:fld>
             <a:endParaRPr lang="en-US"/>
           </a:p>
@@ -40514,6 +40934,365 @@
 </p:sldLayout>
 </file>
 
+<file path=ppt/slideLayouts/slideLayout58.xml><?xml version="1.0" encoding="utf-8"?>
+<p:sldLayout xmlns:a="http://schemas.openxmlformats.org/drawingml/2006/main" xmlns:r="http://schemas.openxmlformats.org/officeDocument/2006/relationships" xmlns:p="http://schemas.openxmlformats.org/presentationml/2006/main" matchingName="Title and body" type="tx">
+  <p:cSld name="Title and body">
+    <p:spTree>
+      <p:nvGrpSpPr>
+        <p:cNvPr id="1" name="Shape 16"/>
+        <p:cNvGrpSpPr/>
+        <p:nvPr/>
+      </p:nvGrpSpPr>
+      <p:grpSpPr>
+        <a:xfrm>
+          <a:off x="0" y="0"/>
+          <a:ext cx="0" cy="0"/>
+          <a:chOff x="0" y="0"/>
+          <a:chExt cx="0" cy="0"/>
+        </a:xfrm>
+      </p:grpSpPr>
+      <p:sp>
+        <p:nvSpPr>
+          <p:cNvPr id="17" name="Google Shape;17;p4"/>
+          <p:cNvSpPr txBox="1">
+            <a:spLocks noGrp="1"/>
+          </p:cNvSpPr>
+          <p:nvPr>
+            <p:ph type="title"/>
+          </p:nvPr>
+        </p:nvSpPr>
+        <p:spPr>
+          <a:xfrm>
+            <a:off x="415600" y="593367"/>
+            <a:ext cx="11360800" cy="763600"/>
+          </a:xfrm>
+          <a:prstGeom prst="rect">
+            <a:avLst/>
+          </a:prstGeom>
+        </p:spPr>
+        <p:txBody>
+          <a:bodyPr spcFirstLastPara="1" wrap="square" lIns="91425" tIns="91425" rIns="91425" bIns="91425" anchor="t" anchorCtr="0">
+            <a:normAutofit/>
+          </a:bodyPr>
+          <a:lstStyle>
+            <a:lvl1pPr lvl="0">
+              <a:spcBef>
+                <a:spcPts val="0"/>
+              </a:spcBef>
+              <a:spcAft>
+                <a:spcPts val="0"/>
+              </a:spcAft>
+              <a:buSzPts val="2800"/>
+              <a:buNone/>
+              <a:defRPr/>
+            </a:lvl1pPr>
+            <a:lvl2pPr lvl="1">
+              <a:spcBef>
+                <a:spcPts val="0"/>
+              </a:spcBef>
+              <a:spcAft>
+                <a:spcPts val="0"/>
+              </a:spcAft>
+              <a:buSzPts val="2800"/>
+              <a:buNone/>
+              <a:defRPr/>
+            </a:lvl2pPr>
+            <a:lvl3pPr lvl="2">
+              <a:spcBef>
+                <a:spcPts val="0"/>
+              </a:spcBef>
+              <a:spcAft>
+                <a:spcPts val="0"/>
+              </a:spcAft>
+              <a:buSzPts val="2800"/>
+              <a:buNone/>
+              <a:defRPr/>
+            </a:lvl3pPr>
+            <a:lvl4pPr lvl="3">
+              <a:spcBef>
+                <a:spcPts val="0"/>
+              </a:spcBef>
+              <a:spcAft>
+                <a:spcPts val="0"/>
+              </a:spcAft>
+              <a:buSzPts val="2800"/>
+              <a:buNone/>
+              <a:defRPr/>
+            </a:lvl4pPr>
+            <a:lvl5pPr lvl="4">
+              <a:spcBef>
+                <a:spcPts val="0"/>
+              </a:spcBef>
+              <a:spcAft>
+                <a:spcPts val="0"/>
+              </a:spcAft>
+              <a:buSzPts val="2800"/>
+              <a:buNone/>
+              <a:defRPr/>
+            </a:lvl5pPr>
+            <a:lvl6pPr lvl="5">
+              <a:spcBef>
+                <a:spcPts val="0"/>
+              </a:spcBef>
+              <a:spcAft>
+                <a:spcPts val="0"/>
+              </a:spcAft>
+              <a:buSzPts val="2800"/>
+              <a:buNone/>
+              <a:defRPr/>
+            </a:lvl6pPr>
+            <a:lvl7pPr lvl="6">
+              <a:spcBef>
+                <a:spcPts val="0"/>
+              </a:spcBef>
+              <a:spcAft>
+                <a:spcPts val="0"/>
+              </a:spcAft>
+              <a:buSzPts val="2800"/>
+              <a:buNone/>
+              <a:defRPr/>
+            </a:lvl7pPr>
+            <a:lvl8pPr lvl="7">
+              <a:spcBef>
+                <a:spcPts val="0"/>
+              </a:spcBef>
+              <a:spcAft>
+                <a:spcPts val="0"/>
+              </a:spcAft>
+              <a:buSzPts val="2800"/>
+              <a:buNone/>
+              <a:defRPr/>
+            </a:lvl8pPr>
+            <a:lvl9pPr lvl="8">
+              <a:spcBef>
+                <a:spcPts val="0"/>
+              </a:spcBef>
+              <a:spcAft>
+                <a:spcPts val="0"/>
+              </a:spcAft>
+              <a:buSzPts val="2800"/>
+              <a:buNone/>
+              <a:defRPr/>
+            </a:lvl9pPr>
+          </a:lstStyle>
+          <a:p>
+            <a:endParaRPr/>
+          </a:p>
+        </p:txBody>
+      </p:sp>
+      <p:sp>
+        <p:nvSpPr>
+          <p:cNvPr id="18" name="Google Shape;18;p4"/>
+          <p:cNvSpPr txBox="1">
+            <a:spLocks noGrp="1"/>
+          </p:cNvSpPr>
+          <p:nvPr>
+            <p:ph type="body" idx="1"/>
+          </p:nvPr>
+        </p:nvSpPr>
+        <p:spPr>
+          <a:xfrm>
+            <a:off x="415600" y="1536633"/>
+            <a:ext cx="11360800" cy="4555200"/>
+          </a:xfrm>
+          <a:prstGeom prst="rect">
+            <a:avLst/>
+          </a:prstGeom>
+        </p:spPr>
+        <p:txBody>
+          <a:bodyPr spcFirstLastPara="1" wrap="square" lIns="91425" tIns="91425" rIns="91425" bIns="91425" anchor="t" anchorCtr="0">
+            <a:normAutofit/>
+          </a:bodyPr>
+          <a:lstStyle>
+            <a:lvl1pPr marL="609585" lvl="0" indent="-457189">
+              <a:spcBef>
+                <a:spcPts val="0"/>
+              </a:spcBef>
+              <a:spcAft>
+                <a:spcPts val="0"/>
+              </a:spcAft>
+              <a:buSzPts val="1800"/>
+              <a:buChar char="●"/>
+              <a:defRPr/>
+            </a:lvl1pPr>
+            <a:lvl2pPr marL="1219170" lvl="1" indent="-423323">
+              <a:spcBef>
+                <a:spcPts val="0"/>
+              </a:spcBef>
+              <a:spcAft>
+                <a:spcPts val="0"/>
+              </a:spcAft>
+              <a:buSzPts val="1400"/>
+              <a:buChar char="○"/>
+              <a:defRPr/>
+            </a:lvl2pPr>
+            <a:lvl3pPr marL="1828754" lvl="2" indent="-423323">
+              <a:spcBef>
+                <a:spcPts val="0"/>
+              </a:spcBef>
+              <a:spcAft>
+                <a:spcPts val="0"/>
+              </a:spcAft>
+              <a:buSzPts val="1400"/>
+              <a:buChar char="■"/>
+              <a:defRPr/>
+            </a:lvl3pPr>
+            <a:lvl4pPr marL="2438339" lvl="3" indent="-423323">
+              <a:spcBef>
+                <a:spcPts val="0"/>
+              </a:spcBef>
+              <a:spcAft>
+                <a:spcPts val="0"/>
+              </a:spcAft>
+              <a:buSzPts val="1400"/>
+              <a:buChar char="●"/>
+              <a:defRPr/>
+            </a:lvl4pPr>
+            <a:lvl5pPr marL="3047924" lvl="4" indent="-423323">
+              <a:spcBef>
+                <a:spcPts val="0"/>
+              </a:spcBef>
+              <a:spcAft>
+                <a:spcPts val="0"/>
+              </a:spcAft>
+              <a:buSzPts val="1400"/>
+              <a:buChar char="○"/>
+              <a:defRPr/>
+            </a:lvl5pPr>
+            <a:lvl6pPr marL="3657509" lvl="5" indent="-423323">
+              <a:spcBef>
+                <a:spcPts val="0"/>
+              </a:spcBef>
+              <a:spcAft>
+                <a:spcPts val="0"/>
+              </a:spcAft>
+              <a:buSzPts val="1400"/>
+              <a:buChar char="■"/>
+              <a:defRPr/>
+            </a:lvl6pPr>
+            <a:lvl7pPr marL="4267093" lvl="6" indent="-423323">
+              <a:spcBef>
+                <a:spcPts val="0"/>
+              </a:spcBef>
+              <a:spcAft>
+                <a:spcPts val="0"/>
+              </a:spcAft>
+              <a:buSzPts val="1400"/>
+              <a:buChar char="●"/>
+              <a:defRPr/>
+            </a:lvl7pPr>
+            <a:lvl8pPr marL="4876678" lvl="7" indent="-423323">
+              <a:spcBef>
+                <a:spcPts val="0"/>
+              </a:spcBef>
+              <a:spcAft>
+                <a:spcPts val="0"/>
+              </a:spcAft>
+              <a:buSzPts val="1400"/>
+              <a:buChar char="○"/>
+              <a:defRPr/>
+            </a:lvl8pPr>
+            <a:lvl9pPr marL="5486263" lvl="8" indent="-423323">
+              <a:spcBef>
+                <a:spcPts val="0"/>
+              </a:spcBef>
+              <a:spcAft>
+                <a:spcPts val="0"/>
+              </a:spcAft>
+              <a:buSzPts val="1400"/>
+              <a:buChar char="■"/>
+              <a:defRPr/>
+            </a:lvl9pPr>
+          </a:lstStyle>
+          <a:p>
+            <a:endParaRPr/>
+          </a:p>
+        </p:txBody>
+      </p:sp>
+      <p:sp>
+        <p:nvSpPr>
+          <p:cNvPr id="19" name="Google Shape;19;p4"/>
+          <p:cNvSpPr txBox="1">
+            <a:spLocks noGrp="1"/>
+          </p:cNvSpPr>
+          <p:nvPr>
+            <p:ph type="sldNum" idx="12"/>
+          </p:nvPr>
+        </p:nvSpPr>
+        <p:spPr>
+          <a:xfrm>
+            <a:off x="11296611" y="6217623"/>
+            <a:ext cx="731600" cy="524800"/>
+          </a:xfrm>
+          <a:prstGeom prst="rect">
+            <a:avLst/>
+          </a:prstGeom>
+        </p:spPr>
+        <p:txBody>
+          <a:bodyPr spcFirstLastPara="1" wrap="square" lIns="91425" tIns="91425" rIns="91425" bIns="91425" anchor="ctr" anchorCtr="0">
+            <a:normAutofit/>
+          </a:bodyPr>
+          <a:lstStyle>
+            <a:lvl1pPr lvl="0">
+              <a:buNone/>
+              <a:defRPr/>
+            </a:lvl1pPr>
+            <a:lvl2pPr lvl="1">
+              <a:buNone/>
+              <a:defRPr/>
+            </a:lvl2pPr>
+            <a:lvl3pPr lvl="2">
+              <a:buNone/>
+              <a:defRPr/>
+            </a:lvl3pPr>
+            <a:lvl4pPr lvl="3">
+              <a:buNone/>
+              <a:defRPr/>
+            </a:lvl4pPr>
+            <a:lvl5pPr lvl="4">
+              <a:buNone/>
+              <a:defRPr/>
+            </a:lvl5pPr>
+            <a:lvl6pPr lvl="5">
+              <a:buNone/>
+              <a:defRPr/>
+            </a:lvl6pPr>
+            <a:lvl7pPr lvl="6">
+              <a:buNone/>
+              <a:defRPr/>
+            </a:lvl7pPr>
+            <a:lvl8pPr lvl="7">
+              <a:buNone/>
+              <a:defRPr/>
+            </a:lvl8pPr>
+            <a:lvl9pPr lvl="8">
+              <a:buNone/>
+              <a:defRPr/>
+            </a:lvl9pPr>
+          </a:lstStyle>
+          <a:p>
+            <a:fld id="{00000000-1234-1234-1234-123412341234}" type="slidenum">
+              <a:rPr lang="en" smtClean="0"/>
+              <a:pPr/>
+              <a:t>‹#›</a:t>
+            </a:fld>
+            <a:endParaRPr lang="en"/>
+          </a:p>
+        </p:txBody>
+      </p:sp>
+    </p:spTree>
+    <p:extLst>
+      <p:ext uri="{BB962C8B-B14F-4D97-AF65-F5344CB8AC3E}">
+        <p14:creationId xmlns:p14="http://schemas.microsoft.com/office/powerpoint/2010/main" val="1367325090"/>
+      </p:ext>
+    </p:extLst>
+  </p:cSld>
+  <p:clrMapOvr>
+    <a:masterClrMapping/>
+  </p:clrMapOvr>
+</p:sldLayout>
+</file>
+
 <file path=ppt/slideLayouts/slideLayout6.xml><?xml version="1.0" encoding="utf-8"?>
 <p:sldLayout xmlns:a="http://schemas.openxmlformats.org/drawingml/2006/main" xmlns:r="http://schemas.openxmlformats.org/officeDocument/2006/relationships" xmlns:p="http://schemas.openxmlformats.org/presentationml/2006/main" preserve="1">
   <p:cSld name="3 Column">
@@ -40781,7 +41560,7 @@
           <a:p>
             <a:fld id="{971AFA9C-17DA-4726-B9E3-ADECF7729AF7}" type="datetimeFigureOut">
               <a:rPr lang="en-US" smtClean="0"/>
-              <a:t>6/19/2026</a:t>
+              <a:t>6/22/2026</a:t>
             </a:fld>
             <a:endParaRPr lang="en-US"/>
           </a:p>
@@ -41297,7 +42076,7 @@
           <a:p>
             <a:fld id="{971AFA9C-17DA-4726-B9E3-ADECF7729AF7}" type="datetimeFigureOut">
               <a:rPr lang="en-US" smtClean="0"/>
-              <a:t>6/19/2026</a:t>
+              <a:t>6/22/2026</a:t>
             </a:fld>
             <a:endParaRPr lang="en-US"/>
           </a:p>
@@ -41981,7 +42760,7 @@
           <a:p>
             <a:fld id="{971AFA9C-17DA-4726-B9E3-ADECF7729AF7}" type="datetimeFigureOut">
               <a:rPr lang="en-US" smtClean="0"/>
-              <a:t>6/19/2026</a:t>
+              <a:t>6/22/2026</a:t>
             </a:fld>
             <a:endParaRPr lang="en-US"/>
           </a:p>
@@ -43074,7 +43853,7 @@
           <a:p>
             <a:fld id="{971AFA9C-17DA-4726-B9E3-ADECF7729AF7}" type="datetimeFigureOut">
               <a:rPr lang="en-US" smtClean="0"/>
-              <a:t>6/19/2026</a:t>
+              <a:t>6/22/2026</a:t>
             </a:fld>
             <a:endParaRPr lang="en-US"/>
           </a:p>
@@ -43767,7 +44546,7 @@
           <p:nvPr/>
         </p:nvPicPr>
         <p:blipFill>
-          <a:blip r:embed="rId26"/>
+          <a:blip r:embed="rId27"/>
           <a:srcRect l="26274" t="67"/>
           <a:stretch>
             <a:fillRect/>
@@ -44020,7 +44799,7 @@
           <a:p>
             <a:fld id="{971AFA9C-17DA-4726-B9E3-ADECF7729AF7}" type="datetimeFigureOut">
               <a:rPr lang="en-US" smtClean="0"/>
-              <a:t>6/19/2026</a:t>
+              <a:t>6/22/2026</a:t>
             </a:fld>
             <a:endParaRPr lang="en-US"/>
           </a:p>
@@ -44086,7 +44865,7 @@
           <p:nvPr/>
         </p:nvPicPr>
         <p:blipFill>
-          <a:blip r:embed="rId27"/>
+          <a:blip r:embed="rId28"/>
           <a:stretch>
             <a:fillRect/>
           </a:stretch>
@@ -44134,6 +44913,7 @@
     <p:sldLayoutId id="2147483716" r:id="rId22"/>
     <p:sldLayoutId id="2147483717" r:id="rId23"/>
     <p:sldLayoutId id="2147483718" r:id="rId24"/>
+    <p:sldLayoutId id="2147483719" r:id="rId25"/>
   </p:sldLayoutIdLst>
   <p:txStyles>
     <p:titleStyle>
@@ -44874,6 +45654,1299 @@
 </file>
 
 <file path=ppt/slides/slide10.xml><?xml version="1.0" encoding="utf-8"?>
+<p:sld xmlns:a="http://schemas.openxmlformats.org/drawingml/2006/main" xmlns:r="http://schemas.openxmlformats.org/officeDocument/2006/relationships" xmlns:p="http://schemas.openxmlformats.org/presentationml/2006/main">
+  <p:cSld>
+    <p:spTree>
+      <p:nvGrpSpPr>
+        <p:cNvPr id="1" name="Shape 74"/>
+        <p:cNvGrpSpPr/>
+        <p:nvPr/>
+      </p:nvGrpSpPr>
+      <p:grpSpPr>
+        <a:xfrm>
+          <a:off x="0" y="0"/>
+          <a:ext cx="0" cy="0"/>
+          <a:chOff x="0" y="0"/>
+          <a:chExt cx="0" cy="0"/>
+        </a:xfrm>
+      </p:grpSpPr>
+      <p:sp>
+        <p:nvSpPr>
+          <p:cNvPr id="75" name="Google Shape;75;p17"/>
+          <p:cNvSpPr txBox="1">
+            <a:spLocks noGrp="1"/>
+          </p:cNvSpPr>
+          <p:nvPr>
+            <p:ph type="body" idx="1"/>
+          </p:nvPr>
+        </p:nvSpPr>
+        <p:spPr>
+          <a:xfrm>
+            <a:off x="415600" y="284900"/>
+            <a:ext cx="11360800" cy="6323600"/>
+          </a:xfrm>
+          <a:prstGeom prst="rect">
+            <a:avLst/>
+          </a:prstGeom>
+        </p:spPr>
+        <p:txBody>
+          <a:bodyPr spcFirstLastPara="1" vert="horz" wrap="square" lIns="121900" tIns="121900" rIns="121900" bIns="121900" spcCol="365760" rtlCol="0" anchor="t" anchorCtr="0">
+            <a:normAutofit/>
+          </a:bodyPr>
+          <a:lstStyle/>
+          <a:p>
+            <a:pPr marL="0" indent="0">
+              <a:buNone/>
+            </a:pPr>
+            <a:r>
+              <a:rPr lang="en" sz="3333" b="1" u="sng"/>
+              <a:t>Problem 2 Assessment</a:t>
+            </a:r>
+            <a:endParaRPr sz="3333" b="1" u="sng"/>
+          </a:p>
+          <a:p>
+            <a:pPr marL="0" indent="0">
+              <a:spcBef>
+                <a:spcPts val="1600"/>
+              </a:spcBef>
+              <a:buNone/>
+            </a:pPr>
+            <a:endParaRPr/>
+          </a:p>
+          <a:p>
+            <a:pPr marL="0" indent="0">
+              <a:spcBef>
+                <a:spcPts val="1600"/>
+              </a:spcBef>
+              <a:spcAft>
+                <a:spcPts val="1600"/>
+              </a:spcAft>
+              <a:buNone/>
+            </a:pPr>
+            <a:endParaRPr/>
+          </a:p>
+        </p:txBody>
+      </p:sp>
+      <p:graphicFrame>
+        <p:nvGraphicFramePr>
+          <p:cNvPr id="76" name="Google Shape;76;p17"/>
+          <p:cNvGraphicFramePr/>
+          <p:nvPr/>
+        </p:nvGraphicFramePr>
+        <p:xfrm>
+          <a:off x="1270000" y="1497933"/>
+          <a:ext cx="9652000" cy="3916440"/>
+        </p:xfrm>
+        <a:graphic>
+          <a:graphicData uri="http://schemas.openxmlformats.org/drawingml/2006/table">
+            <a:tbl>
+              <a:tblPr>
+                <a:noFill/>
+              </a:tblPr>
+              <a:tblGrid>
+                <a:gridCol w="1303533">
+                  <a:extLst>
+                    <a:ext uri="{9D8B030D-6E8A-4147-A177-3AD203B41FA5}">
+                      <a16:colId xmlns:a16="http://schemas.microsoft.com/office/drawing/2014/main" val="20000"/>
+                    </a:ext>
+                  </a:extLst>
+                </a:gridCol>
+                <a:gridCol w="8348467">
+                  <a:extLst>
+                    <a:ext uri="{9D8B030D-6E8A-4147-A177-3AD203B41FA5}">
+                      <a16:colId xmlns:a16="http://schemas.microsoft.com/office/drawing/2014/main" val="20001"/>
+                    </a:ext>
+                  </a:extLst>
+                </a:gridCol>
+              </a:tblGrid>
+              <a:tr h="589240">
+                <a:tc>
+                  <a:txBody>
+                    <a:bodyPr/>
+                    <a:lstStyle/>
+                    <a:p>
+                      <a:pPr marL="0" lvl="0" indent="0" algn="l" rtl="0">
+                        <a:spcBef>
+                          <a:spcPts val="0"/>
+                        </a:spcBef>
+                        <a:spcAft>
+                          <a:spcPts val="0"/>
+                        </a:spcAft>
+                        <a:buNone/>
+                      </a:pPr>
+                      <a:r>
+                        <a:rPr lang="en" sz="2300"/>
+                        <a:t>Grade</a:t>
+                      </a:r>
+                      <a:endParaRPr sz="2300"/>
+                    </a:p>
+                  </a:txBody>
+                  <a:tcPr marL="121900" marR="121900" marT="121900" marB="121900"/>
+                </a:tc>
+                <a:tc>
+                  <a:txBody>
+                    <a:bodyPr/>
+                    <a:lstStyle/>
+                    <a:p>
+                      <a:pPr marL="0" lvl="0" indent="0" algn="l" rtl="0">
+                        <a:spcBef>
+                          <a:spcPts val="0"/>
+                        </a:spcBef>
+                        <a:spcAft>
+                          <a:spcPts val="0"/>
+                        </a:spcAft>
+                        <a:buNone/>
+                      </a:pPr>
+                      <a:r>
+                        <a:rPr lang="en" sz="2300"/>
+                        <a:t>Criteria</a:t>
+                      </a:r>
+                      <a:endParaRPr sz="2300"/>
+                    </a:p>
+                  </a:txBody>
+                  <a:tcPr marL="121900" marR="121900" marT="121900" marB="121900"/>
+                </a:tc>
+                <a:extLst>
+                  <a:ext uri="{0D108BD9-81ED-4DB2-BD59-A6C34878D82A}">
+                    <a16:rowId xmlns:a16="http://schemas.microsoft.com/office/drawing/2014/main" val="10000"/>
+                  </a:ext>
+                </a:extLst>
+              </a:tr>
+              <a:tr h="589240">
+                <a:tc>
+                  <a:txBody>
+                    <a:bodyPr/>
+                    <a:lstStyle/>
+                    <a:p>
+                      <a:pPr marL="0" lvl="0" indent="0" algn="l" rtl="0">
+                        <a:spcBef>
+                          <a:spcPts val="0"/>
+                        </a:spcBef>
+                        <a:spcAft>
+                          <a:spcPts val="0"/>
+                        </a:spcAft>
+                        <a:buNone/>
+                      </a:pPr>
+                      <a:r>
+                        <a:rPr lang="en" sz="2300"/>
+                        <a:t>D</a:t>
+                      </a:r>
+                      <a:endParaRPr sz="2300"/>
+                    </a:p>
+                  </a:txBody>
+                  <a:tcPr marL="121900" marR="121900" marT="121900" marB="121900"/>
+                </a:tc>
+                <a:tc>
+                  <a:txBody>
+                    <a:bodyPr/>
+                    <a:lstStyle/>
+                    <a:p>
+                      <a:pPr marL="0" lvl="0" indent="0" algn="l" rtl="0">
+                        <a:spcBef>
+                          <a:spcPts val="0"/>
+                        </a:spcBef>
+                        <a:spcAft>
+                          <a:spcPts val="0"/>
+                        </a:spcAft>
+                        <a:buNone/>
+                      </a:pPr>
+                      <a:r>
+                        <a:rPr lang="en" sz="2300"/>
+                        <a:t>You correctly solve the given deal</a:t>
+                      </a:r>
+                      <a:endParaRPr sz="2300"/>
+                    </a:p>
+                  </a:txBody>
+                  <a:tcPr marL="121900" marR="121900" marT="121900" marB="121900"/>
+                </a:tc>
+                <a:extLst>
+                  <a:ext uri="{0D108BD9-81ED-4DB2-BD59-A6C34878D82A}">
+                    <a16:rowId xmlns:a16="http://schemas.microsoft.com/office/drawing/2014/main" val="10001"/>
+                  </a:ext>
+                </a:extLst>
+              </a:tr>
+              <a:tr h="589240">
+                <a:tc>
+                  <a:txBody>
+                    <a:bodyPr/>
+                    <a:lstStyle/>
+                    <a:p>
+                      <a:pPr marL="0" lvl="0" indent="0" algn="l" rtl="0">
+                        <a:spcBef>
+                          <a:spcPts val="0"/>
+                        </a:spcBef>
+                        <a:spcAft>
+                          <a:spcPts val="0"/>
+                        </a:spcAft>
+                        <a:buNone/>
+                      </a:pPr>
+                      <a:r>
+                        <a:rPr lang="en" sz="2300"/>
+                        <a:t>C</a:t>
+                      </a:r>
+                      <a:endParaRPr sz="2300"/>
+                    </a:p>
+                  </a:txBody>
+                  <a:tcPr marL="121900" marR="121900" marT="121900" marB="121900"/>
+                </a:tc>
+                <a:tc>
+                  <a:txBody>
+                    <a:bodyPr/>
+                    <a:lstStyle/>
+                    <a:p>
+                      <a:pPr marL="0" lvl="0" indent="0" algn="l" rtl="0">
+                        <a:spcBef>
+                          <a:spcPts val="0"/>
+                        </a:spcBef>
+                        <a:spcAft>
+                          <a:spcPts val="0"/>
+                        </a:spcAft>
+                        <a:buNone/>
+                      </a:pPr>
+                      <a:r>
+                        <a:rPr lang="en" sz="2300"/>
+                        <a:t>You write a function to determine price per in squared.</a:t>
+                      </a:r>
+                      <a:endParaRPr sz="2300"/>
+                    </a:p>
+                  </a:txBody>
+                  <a:tcPr marL="121900" marR="121900" marT="121900" marB="121900"/>
+                </a:tc>
+                <a:extLst>
+                  <a:ext uri="{0D108BD9-81ED-4DB2-BD59-A6C34878D82A}">
+                    <a16:rowId xmlns:a16="http://schemas.microsoft.com/office/drawing/2014/main" val="10002"/>
+                  </a:ext>
+                </a:extLst>
+              </a:tr>
+              <a:tr h="589240">
+                <a:tc>
+                  <a:txBody>
+                    <a:bodyPr/>
+                    <a:lstStyle/>
+                    <a:p>
+                      <a:pPr marL="0" lvl="0" indent="0" algn="l" rtl="0">
+                        <a:spcBef>
+                          <a:spcPts val="0"/>
+                        </a:spcBef>
+                        <a:spcAft>
+                          <a:spcPts val="0"/>
+                        </a:spcAft>
+                        <a:buNone/>
+                      </a:pPr>
+                      <a:r>
+                        <a:rPr lang="en" sz="2300"/>
+                        <a:t>B</a:t>
+                      </a:r>
+                      <a:endParaRPr sz="2300"/>
+                    </a:p>
+                  </a:txBody>
+                  <a:tcPr marL="121900" marR="121900" marT="121900" marB="121900"/>
+                </a:tc>
+                <a:tc>
+                  <a:txBody>
+                    <a:bodyPr/>
+                    <a:lstStyle/>
+                    <a:p>
+                      <a:pPr marL="0" lvl="0" indent="0" algn="l" rtl="0">
+                        <a:spcBef>
+                          <a:spcPts val="0"/>
+                        </a:spcBef>
+                        <a:spcAft>
+                          <a:spcPts val="0"/>
+                        </a:spcAft>
+                        <a:buNone/>
+                      </a:pPr>
+                      <a:r>
+                        <a:rPr lang="en" sz="2300"/>
+                        <a:t>You write a function to compare prices and quantity of pizzas.</a:t>
+                      </a:r>
+                      <a:endParaRPr sz="2300"/>
+                    </a:p>
+                  </a:txBody>
+                  <a:tcPr marL="121900" marR="121900" marT="121900" marB="121900"/>
+                </a:tc>
+                <a:extLst>
+                  <a:ext uri="{0D108BD9-81ED-4DB2-BD59-A6C34878D82A}">
+                    <a16:rowId xmlns:a16="http://schemas.microsoft.com/office/drawing/2014/main" val="10003"/>
+                  </a:ext>
+                </a:extLst>
+              </a:tr>
+              <a:tr h="934680">
+                <a:tc>
+                  <a:txBody>
+                    <a:bodyPr/>
+                    <a:lstStyle/>
+                    <a:p>
+                      <a:pPr marL="0" lvl="0" indent="0" algn="l" rtl="0">
+                        <a:spcBef>
+                          <a:spcPts val="0"/>
+                        </a:spcBef>
+                        <a:spcAft>
+                          <a:spcPts val="0"/>
+                        </a:spcAft>
+                        <a:buNone/>
+                      </a:pPr>
+                      <a:r>
+                        <a:rPr lang="en" sz="2300"/>
+                        <a:t>A</a:t>
+                      </a:r>
+                      <a:endParaRPr sz="2300"/>
+                    </a:p>
+                  </a:txBody>
+                  <a:tcPr marL="121900" marR="121900" marT="121900" marB="121900"/>
+                </a:tc>
+                <a:tc>
+                  <a:txBody>
+                    <a:bodyPr/>
+                    <a:lstStyle/>
+                    <a:p>
+                      <a:pPr marL="0" lvl="0" indent="0" algn="l" rtl="0">
+                        <a:spcBef>
+                          <a:spcPts val="0"/>
+                        </a:spcBef>
+                        <a:spcAft>
+                          <a:spcPts val="0"/>
+                        </a:spcAft>
+                        <a:buNone/>
+                      </a:pPr>
+                      <a:r>
+                        <a:rPr lang="en" sz="2300"/>
+                        <a:t>Your python script successfully opens webpages based on the outcome.</a:t>
+                      </a:r>
+                      <a:endParaRPr sz="2300"/>
+                    </a:p>
+                  </a:txBody>
+                  <a:tcPr marL="121900" marR="121900" marT="121900" marB="121900"/>
+                </a:tc>
+                <a:extLst>
+                  <a:ext uri="{0D108BD9-81ED-4DB2-BD59-A6C34878D82A}">
+                    <a16:rowId xmlns:a16="http://schemas.microsoft.com/office/drawing/2014/main" val="10004"/>
+                  </a:ext>
+                </a:extLst>
+              </a:tr>
+              <a:tr h="589240">
+                <a:tc>
+                  <a:txBody>
+                    <a:bodyPr/>
+                    <a:lstStyle/>
+                    <a:p>
+                      <a:pPr marL="0" lvl="0" indent="0" algn="l" rtl="0">
+                        <a:spcBef>
+                          <a:spcPts val="0"/>
+                        </a:spcBef>
+                        <a:spcAft>
+                          <a:spcPts val="0"/>
+                        </a:spcAft>
+                        <a:buNone/>
+                      </a:pPr>
+                      <a:r>
+                        <a:rPr lang="en" sz="2300"/>
+                        <a:t>A+</a:t>
+                      </a:r>
+                      <a:endParaRPr sz="2300"/>
+                    </a:p>
+                  </a:txBody>
+                  <a:tcPr marL="121900" marR="121900" marT="121900" marB="121900"/>
+                </a:tc>
+                <a:tc>
+                  <a:txBody>
+                    <a:bodyPr/>
+                    <a:lstStyle/>
+                    <a:p>
+                      <a:pPr marL="0" lvl="0" indent="0" algn="l" rtl="0">
+                        <a:spcBef>
+                          <a:spcPts val="0"/>
+                        </a:spcBef>
+                        <a:spcAft>
+                          <a:spcPts val="0"/>
+                        </a:spcAft>
+                        <a:buNone/>
+                      </a:pPr>
+                      <a:r>
+                        <a:rPr lang="en" sz="2300"/>
+                        <a:t>Added ASCII Art</a:t>
+                      </a:r>
+                      <a:endParaRPr sz="2300"/>
+                    </a:p>
+                  </a:txBody>
+                  <a:tcPr marL="121900" marR="121900" marT="121900" marB="121900"/>
+                </a:tc>
+                <a:extLst>
+                  <a:ext uri="{0D108BD9-81ED-4DB2-BD59-A6C34878D82A}">
+                    <a16:rowId xmlns:a16="http://schemas.microsoft.com/office/drawing/2014/main" val="10005"/>
+                  </a:ext>
+                </a:extLst>
+              </a:tr>
+            </a:tbl>
+          </a:graphicData>
+        </a:graphic>
+      </p:graphicFrame>
+    </p:spTree>
+  </p:cSld>
+  <p:clrMapOvr>
+    <a:masterClrMapping/>
+  </p:clrMapOvr>
+</p:sld>
+</file>
+
+<file path=ppt/slides/slide11.xml><?xml version="1.0" encoding="utf-8"?>
+<p:sld xmlns:a="http://schemas.openxmlformats.org/drawingml/2006/main" xmlns:r="http://schemas.openxmlformats.org/officeDocument/2006/relationships" xmlns:p="http://schemas.openxmlformats.org/presentationml/2006/main">
+  <p:cSld>
+    <p:spTree>
+      <p:nvGrpSpPr>
+        <p:cNvPr id="1" name="">
+          <a:extLst>
+            <a:ext uri="{FF2B5EF4-FFF2-40B4-BE49-F238E27FC236}">
+              <a16:creationId xmlns:a16="http://schemas.microsoft.com/office/drawing/2014/main" id="{F0C5B1A7-8E0E-589E-EB86-60B4773E061F}"/>
+            </a:ext>
+          </a:extLst>
+        </p:cNvPr>
+        <p:cNvGrpSpPr/>
+        <p:nvPr/>
+      </p:nvGrpSpPr>
+      <p:grpSpPr>
+        <a:xfrm>
+          <a:off x="0" y="0"/>
+          <a:ext cx="0" cy="0"/>
+          <a:chOff x="0" y="0"/>
+          <a:chExt cx="0" cy="0"/>
+        </a:xfrm>
+      </p:grpSpPr>
+      <p:sp>
+        <p:nvSpPr>
+          <p:cNvPr id="2" name="Title 1">
+            <a:extLst>
+              <a:ext uri="{FF2B5EF4-FFF2-40B4-BE49-F238E27FC236}">
+                <a16:creationId xmlns:a16="http://schemas.microsoft.com/office/drawing/2014/main" id="{5F1A3DAE-54C2-F616-33A3-63FF6D72FBE3}"/>
+              </a:ext>
+            </a:extLst>
+          </p:cNvPr>
+          <p:cNvSpPr>
+            <a:spLocks noGrp="1"/>
+          </p:cNvSpPr>
+          <p:nvPr>
+            <p:ph type="title"/>
+          </p:nvPr>
+        </p:nvSpPr>
+        <p:spPr>
+          <a:xfrm>
+            <a:off x="2793283" y="1181186"/>
+            <a:ext cx="7053360" cy="780276"/>
+          </a:xfrm>
+        </p:spPr>
+        <p:txBody>
+          <a:bodyPr/>
+          <a:lstStyle/>
+          <a:p>
+            <a:r>
+              <a:rPr lang="en-US" dirty="0"/>
+              <a:t>Let’s make this a function:</a:t>
+            </a:r>
+          </a:p>
+        </p:txBody>
+      </p:sp>
+      <p:pic>
+        <p:nvPicPr>
+          <p:cNvPr id="3" name="Picture 2" descr="The compound interest formula: A = P(1 + r/n)^nt">
+            <a:extLst>
+              <a:ext uri="{FF2B5EF4-FFF2-40B4-BE49-F238E27FC236}">
+                <a16:creationId xmlns:a16="http://schemas.microsoft.com/office/drawing/2014/main" id="{28EB7F59-C3C8-A0C1-2E1A-91BCEE397C42}"/>
+              </a:ext>
+            </a:extLst>
+          </p:cNvPr>
+          <p:cNvPicPr>
+            <a:picLocks noChangeAspect="1"/>
+          </p:cNvPicPr>
+          <p:nvPr/>
+        </p:nvPicPr>
+        <p:blipFill>
+          <a:blip r:embed="rId3"/>
+          <a:stretch>
+            <a:fillRect/>
+          </a:stretch>
+        </p:blipFill>
+        <p:spPr>
+          <a:xfrm>
+            <a:off x="3704565" y="1851046"/>
+            <a:ext cx="3956700" cy="2154880"/>
+          </a:xfrm>
+          <a:prstGeom prst="rect">
+            <a:avLst/>
+          </a:prstGeom>
+        </p:spPr>
+      </p:pic>
+      <p:graphicFrame>
+        <p:nvGraphicFramePr>
+          <p:cNvPr id="4" name="Table 3">
+            <a:extLst>
+              <a:ext uri="{FF2B5EF4-FFF2-40B4-BE49-F238E27FC236}">
+                <a16:creationId xmlns:a16="http://schemas.microsoft.com/office/drawing/2014/main" id="{09D2CF20-5FF3-CF01-AD9F-9B2D15DA2168}"/>
+              </a:ext>
+            </a:extLst>
+          </p:cNvPr>
+          <p:cNvGraphicFramePr>
+            <a:graphicFrameLocks noGrp="1"/>
+          </p:cNvGraphicFramePr>
+          <p:nvPr>
+            <p:extLst>
+              <p:ext uri="{D42A27DB-BD31-4B8C-83A1-F6EECF244321}">
+                <p14:modId xmlns:p14="http://schemas.microsoft.com/office/powerpoint/2010/main" val="1262173274"/>
+              </p:ext>
+            </p:extLst>
+          </p:nvPr>
+        </p:nvGraphicFramePr>
+        <p:xfrm>
+          <a:off x="423511" y="4153514"/>
+          <a:ext cx="10518809" cy="2438400"/>
+        </p:xfrm>
+        <a:graphic>
+          <a:graphicData uri="http://schemas.openxmlformats.org/drawingml/2006/table">
+            <a:tbl>
+              <a:tblPr firstRow="1" bandRow="1">
+                <a:tableStyleId>{5C22544A-7EE6-4342-B048-85BDC9FD1C3A}</a:tableStyleId>
+              </a:tblPr>
+              <a:tblGrid>
+                <a:gridCol w="1753135">
+                  <a:extLst>
+                    <a:ext uri="{9D8B030D-6E8A-4147-A177-3AD203B41FA5}">
+                      <a16:colId xmlns:a16="http://schemas.microsoft.com/office/drawing/2014/main" val="1599770990"/>
+                    </a:ext>
+                  </a:extLst>
+                </a:gridCol>
+                <a:gridCol w="1753135">
+                  <a:extLst>
+                    <a:ext uri="{9D8B030D-6E8A-4147-A177-3AD203B41FA5}">
+                      <a16:colId xmlns:a16="http://schemas.microsoft.com/office/drawing/2014/main" val="2076677805"/>
+                    </a:ext>
+                  </a:extLst>
+                </a:gridCol>
+                <a:gridCol w="1753135">
+                  <a:extLst>
+                    <a:ext uri="{9D8B030D-6E8A-4147-A177-3AD203B41FA5}">
+                      <a16:colId xmlns:a16="http://schemas.microsoft.com/office/drawing/2014/main" val="4293853211"/>
+                    </a:ext>
+                  </a:extLst>
+                </a:gridCol>
+                <a:gridCol w="1992087">
+                  <a:extLst>
+                    <a:ext uri="{9D8B030D-6E8A-4147-A177-3AD203B41FA5}">
+                      <a16:colId xmlns:a16="http://schemas.microsoft.com/office/drawing/2014/main" val="2141661481"/>
+                    </a:ext>
+                  </a:extLst>
+                </a:gridCol>
+                <a:gridCol w="1514182">
+                  <a:extLst>
+                    <a:ext uri="{9D8B030D-6E8A-4147-A177-3AD203B41FA5}">
+                      <a16:colId xmlns:a16="http://schemas.microsoft.com/office/drawing/2014/main" val="1863223125"/>
+                    </a:ext>
+                  </a:extLst>
+                </a:gridCol>
+                <a:gridCol w="1753135">
+                  <a:extLst>
+                    <a:ext uri="{9D8B030D-6E8A-4147-A177-3AD203B41FA5}">
+                      <a16:colId xmlns:a16="http://schemas.microsoft.com/office/drawing/2014/main" val="2610029996"/>
+                    </a:ext>
+                  </a:extLst>
+                </a:gridCol>
+              </a:tblGrid>
+              <a:tr h="269217">
+                <a:tc>
+                  <a:txBody>
+                    <a:bodyPr/>
+                    <a:lstStyle/>
+                    <a:p>
+                      <a:r>
+                        <a:rPr lang="en-US" dirty="0"/>
+                        <a:t>Desc.</a:t>
+                      </a:r>
+                    </a:p>
+                  </a:txBody>
+                  <a:tcPr/>
+                </a:tc>
+                <a:tc>
+                  <a:txBody>
+                    <a:bodyPr/>
+                    <a:lstStyle/>
+                    <a:p>
+                      <a:r>
+                        <a:rPr lang="en-US" dirty="0"/>
+                        <a:t>Principal</a:t>
+                      </a:r>
+                    </a:p>
+                  </a:txBody>
+                  <a:tcPr/>
+                </a:tc>
+                <a:tc>
+                  <a:txBody>
+                    <a:bodyPr/>
+                    <a:lstStyle/>
+                    <a:p>
+                      <a:r>
+                        <a:rPr lang="en-US" dirty="0"/>
+                        <a:t>Rate</a:t>
+                      </a:r>
+                    </a:p>
+                  </a:txBody>
+                  <a:tcPr/>
+                </a:tc>
+                <a:tc>
+                  <a:txBody>
+                    <a:bodyPr/>
+                    <a:lstStyle/>
+                    <a:p>
+                      <a:r>
+                        <a:rPr lang="en-US" dirty="0"/>
+                        <a:t># of times compounded annually</a:t>
+                      </a:r>
+                    </a:p>
+                  </a:txBody>
+                  <a:tcPr/>
+                </a:tc>
+                <a:tc>
+                  <a:txBody>
+                    <a:bodyPr/>
+                    <a:lstStyle/>
+                    <a:p>
+                      <a:r>
+                        <a:rPr lang="en-US" dirty="0"/>
+                        <a:t>Years</a:t>
+                      </a:r>
+                    </a:p>
+                  </a:txBody>
+                  <a:tcPr/>
+                </a:tc>
+                <a:tc>
+                  <a:txBody>
+                    <a:bodyPr/>
+                    <a:lstStyle/>
+                    <a:p>
+                      <a:r>
+                        <a:rPr lang="en-US" dirty="0"/>
+                        <a:t>Output</a:t>
+                      </a:r>
+                    </a:p>
+                  </a:txBody>
+                  <a:tcPr/>
+                </a:tc>
+                <a:extLst>
+                  <a:ext uri="{0D108BD9-81ED-4DB2-BD59-A6C34878D82A}">
+                    <a16:rowId xmlns:a16="http://schemas.microsoft.com/office/drawing/2014/main" val="3444101573"/>
+                  </a:ext>
+                </a:extLst>
+              </a:tr>
+              <a:tr h="269217">
+                <a:tc>
+                  <a:txBody>
+                    <a:bodyPr/>
+                    <a:lstStyle/>
+                    <a:p>
+                      <a:r>
+                        <a:rPr lang="en-US" dirty="0"/>
+                        <a:t>Normal Savings Account</a:t>
+                      </a:r>
+                    </a:p>
+                  </a:txBody>
+                  <a:tcPr/>
+                </a:tc>
+                <a:tc>
+                  <a:txBody>
+                    <a:bodyPr/>
+                    <a:lstStyle/>
+                    <a:p>
+                      <a:r>
+                        <a:rPr lang="en-US" dirty="0"/>
+                        <a:t>1000</a:t>
+                      </a:r>
+                    </a:p>
+                  </a:txBody>
+                  <a:tcPr/>
+                </a:tc>
+                <a:tc>
+                  <a:txBody>
+                    <a:bodyPr/>
+                    <a:lstStyle/>
+                    <a:p>
+                      <a:r>
+                        <a:rPr lang="en-US" dirty="0"/>
+                        <a:t>0.0061</a:t>
+                      </a:r>
+                    </a:p>
+                  </a:txBody>
+                  <a:tcPr/>
+                </a:tc>
+                <a:tc>
+                  <a:txBody>
+                    <a:bodyPr/>
+                    <a:lstStyle/>
+                    <a:p>
+                      <a:r>
+                        <a:rPr lang="en-US" dirty="0"/>
+                        <a:t>1</a:t>
+                      </a:r>
+                    </a:p>
+                  </a:txBody>
+                  <a:tcPr/>
+                </a:tc>
+                <a:tc>
+                  <a:txBody>
+                    <a:bodyPr/>
+                    <a:lstStyle/>
+                    <a:p>
+                      <a:r>
+                        <a:rPr lang="en-US" dirty="0"/>
+                        <a:t>10</a:t>
+                      </a:r>
+                    </a:p>
+                  </a:txBody>
+                  <a:tcPr/>
+                </a:tc>
+                <a:tc>
+                  <a:txBody>
+                    <a:bodyPr/>
+                    <a:lstStyle/>
+                    <a:p>
+                      <a:r>
+                        <a:rPr lang="en-US" dirty="0"/>
+                        <a:t>$1062.70</a:t>
+                      </a:r>
+                    </a:p>
+                  </a:txBody>
+                  <a:tcPr/>
+                </a:tc>
+                <a:extLst>
+                  <a:ext uri="{0D108BD9-81ED-4DB2-BD59-A6C34878D82A}">
+                    <a16:rowId xmlns:a16="http://schemas.microsoft.com/office/drawing/2014/main" val="2415867046"/>
+                  </a:ext>
+                </a:extLst>
+              </a:tr>
+              <a:tr h="269217">
+                <a:tc>
+                  <a:txBody>
+                    <a:bodyPr/>
+                    <a:lstStyle/>
+                    <a:p>
+                      <a:r>
+                        <a:rPr lang="en-US" dirty="0"/>
+                        <a:t>Money Market Account (Amex)</a:t>
+                      </a:r>
+                    </a:p>
+                  </a:txBody>
+                  <a:tcPr/>
+                </a:tc>
+                <a:tc>
+                  <a:txBody>
+                    <a:bodyPr/>
+                    <a:lstStyle/>
+                    <a:p>
+                      <a:r>
+                        <a:rPr lang="en-US" dirty="0"/>
+                        <a:t>1000</a:t>
+                      </a:r>
+                    </a:p>
+                  </a:txBody>
+                  <a:tcPr/>
+                </a:tc>
+                <a:tc>
+                  <a:txBody>
+                    <a:bodyPr/>
+                    <a:lstStyle/>
+                    <a:p>
+                      <a:r>
+                        <a:rPr lang="en-US" dirty="0"/>
+                        <a:t>0.031</a:t>
+                      </a:r>
+                    </a:p>
+                  </a:txBody>
+                  <a:tcPr/>
+                </a:tc>
+                <a:tc>
+                  <a:txBody>
+                    <a:bodyPr/>
+                    <a:lstStyle/>
+                    <a:p>
+                      <a:r>
+                        <a:rPr lang="en-US" dirty="0"/>
+                        <a:t>1</a:t>
+                      </a:r>
+                    </a:p>
+                  </a:txBody>
+                  <a:tcPr/>
+                </a:tc>
+                <a:tc>
+                  <a:txBody>
+                    <a:bodyPr/>
+                    <a:lstStyle/>
+                    <a:p>
+                      <a:r>
+                        <a:rPr lang="en-US" dirty="0"/>
+                        <a:t>10</a:t>
+                      </a:r>
+                    </a:p>
+                  </a:txBody>
+                  <a:tcPr/>
+                </a:tc>
+                <a:tc>
+                  <a:txBody>
+                    <a:bodyPr/>
+                    <a:lstStyle/>
+                    <a:p>
+                      <a:r>
+                        <a:rPr lang="en-US" dirty="0"/>
+                        <a:t>$1357.02</a:t>
+                      </a:r>
+                    </a:p>
+                  </a:txBody>
+                  <a:tcPr/>
+                </a:tc>
+                <a:extLst>
+                  <a:ext uri="{0D108BD9-81ED-4DB2-BD59-A6C34878D82A}">
+                    <a16:rowId xmlns:a16="http://schemas.microsoft.com/office/drawing/2014/main" val="3427481328"/>
+                  </a:ext>
+                </a:extLst>
+              </a:tr>
+              <a:tr h="269217">
+                <a:tc>
+                  <a:txBody>
+                    <a:bodyPr/>
+                    <a:lstStyle/>
+                    <a:p>
+                      <a:r>
+                        <a:rPr lang="en-US" dirty="0"/>
+                        <a:t>Index Fund</a:t>
+                      </a:r>
+                    </a:p>
+                  </a:txBody>
+                  <a:tcPr/>
+                </a:tc>
+                <a:tc>
+                  <a:txBody>
+                    <a:bodyPr/>
+                    <a:lstStyle/>
+                    <a:p>
+                      <a:r>
+                        <a:rPr lang="en-US" dirty="0"/>
+                        <a:t>1000</a:t>
+                      </a:r>
+                    </a:p>
+                  </a:txBody>
+                  <a:tcPr/>
+                </a:tc>
+                <a:tc>
+                  <a:txBody>
+                    <a:bodyPr/>
+                    <a:lstStyle/>
+                    <a:p>
+                      <a:r>
+                        <a:rPr lang="en-US" dirty="0"/>
+                        <a:t>0.07</a:t>
+                      </a:r>
+                    </a:p>
+                  </a:txBody>
+                  <a:tcPr/>
+                </a:tc>
+                <a:tc>
+                  <a:txBody>
+                    <a:bodyPr/>
+                    <a:lstStyle/>
+                    <a:p>
+                      <a:r>
+                        <a:rPr lang="en-US" dirty="0"/>
+                        <a:t>1</a:t>
+                      </a:r>
+                    </a:p>
+                  </a:txBody>
+                  <a:tcPr/>
+                </a:tc>
+                <a:tc>
+                  <a:txBody>
+                    <a:bodyPr/>
+                    <a:lstStyle/>
+                    <a:p>
+                      <a:r>
+                        <a:rPr lang="en-US" dirty="0"/>
+                        <a:t>10</a:t>
+                      </a:r>
+                    </a:p>
+                  </a:txBody>
+                  <a:tcPr/>
+                </a:tc>
+                <a:tc>
+                  <a:txBody>
+                    <a:bodyPr/>
+                    <a:lstStyle/>
+                    <a:p>
+                      <a:r>
+                        <a:rPr lang="en-US" dirty="0"/>
+                        <a:t>$1967.15</a:t>
+                      </a:r>
+                    </a:p>
+                  </a:txBody>
+                  <a:tcPr/>
+                </a:tc>
+                <a:extLst>
+                  <a:ext uri="{0D108BD9-81ED-4DB2-BD59-A6C34878D82A}">
+                    <a16:rowId xmlns:a16="http://schemas.microsoft.com/office/drawing/2014/main" val="3484013442"/>
+                  </a:ext>
+                </a:extLst>
+              </a:tr>
+            </a:tbl>
+          </a:graphicData>
+        </a:graphic>
+      </p:graphicFrame>
+      <p:sp>
+        <p:nvSpPr>
+          <p:cNvPr id="6" name="TextBox 5">
+            <a:extLst>
+              <a:ext uri="{FF2B5EF4-FFF2-40B4-BE49-F238E27FC236}">
+                <a16:creationId xmlns:a16="http://schemas.microsoft.com/office/drawing/2014/main" id="{18F9CE0F-A31D-0778-0E05-B216B09F4DA2}"/>
+              </a:ext>
+            </a:extLst>
+          </p:cNvPr>
+          <p:cNvSpPr txBox="1"/>
+          <p:nvPr/>
+        </p:nvSpPr>
+        <p:spPr>
+          <a:xfrm>
+            <a:off x="222359" y="201022"/>
+            <a:ext cx="6097604" cy="369332"/>
+          </a:xfrm>
+          <a:prstGeom prst="rect">
+            <a:avLst/>
+          </a:prstGeom>
+          <a:noFill/>
+        </p:spPr>
+        <p:txBody>
+          <a:bodyPr wrap="square">
+            <a:spAutoFit/>
+          </a:bodyPr>
+          <a:lstStyle/>
+          <a:p>
+            <a:pPr marL="0" indent="0">
+              <a:buNone/>
+            </a:pPr>
+            <a:r>
+              <a:rPr lang="en-US" sz="1800" b="1" u="sng" dirty="0"/>
+              <a:t>Pre Class Problem 3 – A simple function (20 min)</a:t>
+            </a:r>
+          </a:p>
+        </p:txBody>
+      </p:sp>
+    </p:spTree>
+    <p:extLst>
+      <p:ext uri="{BB962C8B-B14F-4D97-AF65-F5344CB8AC3E}">
+        <p14:creationId xmlns:p14="http://schemas.microsoft.com/office/powerpoint/2010/main" val="3180408656"/>
+      </p:ext>
+    </p:extLst>
+  </p:cSld>
+  <p:clrMapOvr>
+    <a:masterClrMapping/>
+  </p:clrMapOvr>
+  <p:timing>
+    <p:tnLst>
+      <p:par>
+        <p:cTn id="1" dur="indefinite" restart="never" nodeType="tmRoot">
+          <p:childTnLst>
+            <p:seq concurrent="1" nextAc="seek">
+              <p:cTn id="2" dur="indefinite" nodeType="mainSeq">
+                <p:childTnLst>
+                  <p:par>
+                    <p:cTn id="3" fill="hold">
+                      <p:stCondLst>
+                        <p:cond delay="indefinite"/>
+                      </p:stCondLst>
+                      <p:childTnLst>
+                        <p:par>
+                          <p:cTn id="4" fill="hold">
+                            <p:stCondLst>
+                              <p:cond delay="0"/>
+                            </p:stCondLst>
+                            <p:childTnLst>
+                              <p:par>
+                                <p:cTn id="5" presetID="1" presetClass="entr" presetSubtype="0" fill="hold" nodeType="clickEffect">
+                                  <p:stCondLst>
+                                    <p:cond delay="0"/>
+                                  </p:stCondLst>
+                                  <p:childTnLst>
+                                    <p:set>
+                                      <p:cBhvr>
+                                        <p:cTn id="6" dur="1" fill="hold">
+                                          <p:stCondLst>
+                                            <p:cond delay="0"/>
+                                          </p:stCondLst>
+                                        </p:cTn>
+                                        <p:tgtEl>
+                                          <p:spTgt spid="4"/>
+                                        </p:tgtEl>
+                                        <p:attrNameLst>
+                                          <p:attrName>style.visibility</p:attrName>
+                                        </p:attrNameLst>
+                                      </p:cBhvr>
+                                      <p:to>
+                                        <p:strVal val="visible"/>
+                                      </p:to>
+                                    </p:set>
+                                  </p:childTnLst>
+                                </p:cTn>
+                              </p:par>
+                            </p:childTnLst>
+                          </p:cTn>
+                        </p:par>
+                      </p:childTnLst>
+                    </p:cTn>
+                  </p:par>
+                </p:childTnLst>
+              </p:cTn>
+              <p:prevCondLst>
+                <p:cond evt="onPrev" delay="0">
+                  <p:tgtEl>
+                    <p:sldTgt/>
+                  </p:tgtEl>
+                </p:cond>
+              </p:prevCondLst>
+              <p:nextCondLst>
+                <p:cond evt="onNext" delay="0">
+                  <p:tgtEl>
+                    <p:sldTgt/>
+                  </p:tgtEl>
+                </p:cond>
+              </p:nextCondLst>
+            </p:seq>
+          </p:childTnLst>
+        </p:cTn>
+      </p:par>
+    </p:tnLst>
+  </p:timing>
+</p:sld>
+</file>
+
+<file path=ppt/slides/slide12.xml><?xml version="1.0" encoding="utf-8"?>
+<p:sld xmlns:a="http://schemas.openxmlformats.org/drawingml/2006/main" xmlns:r="http://schemas.openxmlformats.org/officeDocument/2006/relationships" xmlns:p="http://schemas.openxmlformats.org/presentationml/2006/main">
+  <p:cSld>
+    <p:spTree>
+      <p:nvGrpSpPr>
+        <p:cNvPr id="1" name=""/>
+        <p:cNvGrpSpPr/>
+        <p:nvPr/>
+      </p:nvGrpSpPr>
+      <p:grpSpPr>
+        <a:xfrm>
+          <a:off x="0" y="0"/>
+          <a:ext cx="0" cy="0"/>
+          <a:chOff x="0" y="0"/>
+          <a:chExt cx="0" cy="0"/>
+        </a:xfrm>
+      </p:grpSpPr>
+      <p:sp>
+        <p:nvSpPr>
+          <p:cNvPr id="2" name="Title 1">
+            <a:extLst>
+              <a:ext uri="{FF2B5EF4-FFF2-40B4-BE49-F238E27FC236}">
+                <a16:creationId xmlns:a16="http://schemas.microsoft.com/office/drawing/2014/main" id="{57EB4430-1F71-D899-34E4-0D4105CCE823}"/>
+              </a:ext>
+            </a:extLst>
+          </p:cNvPr>
+          <p:cNvSpPr>
+            <a:spLocks noGrp="1"/>
+          </p:cNvSpPr>
+          <p:nvPr>
+            <p:ph type="title"/>
+          </p:nvPr>
+        </p:nvSpPr>
+        <p:spPr/>
+        <p:txBody>
+          <a:bodyPr/>
+          <a:lstStyle/>
+          <a:p>
+            <a:r>
+              <a:rPr lang="en-US" dirty="0"/>
+              <a:t>Today’s Lesson Objectives</a:t>
+            </a:r>
+          </a:p>
+        </p:txBody>
+      </p:sp>
+      <p:sp>
+        <p:nvSpPr>
+          <p:cNvPr id="3" name="Content Placeholder 2">
+            <a:extLst>
+              <a:ext uri="{FF2B5EF4-FFF2-40B4-BE49-F238E27FC236}">
+                <a16:creationId xmlns:a16="http://schemas.microsoft.com/office/drawing/2014/main" id="{E76FF94A-3BCA-070D-C682-367F5F0F327C}"/>
+              </a:ext>
+            </a:extLst>
+          </p:cNvPr>
+          <p:cNvSpPr>
+            <a:spLocks noGrp="1"/>
+          </p:cNvSpPr>
+          <p:nvPr>
+            <p:ph type="body" sz="quarter" idx="11"/>
+          </p:nvPr>
+        </p:nvSpPr>
+        <p:spPr/>
+        <p:txBody>
+          <a:bodyPr/>
+          <a:lstStyle/>
+          <a:p>
+            <a:pPr marL="457200" indent="-457200">
+              <a:buFont typeface="Arial" panose="020B0604020202020204" pitchFamily="34" charset="0"/>
+              <a:buChar char="•"/>
+            </a:pPr>
+            <a:r>
+              <a:rPr lang="en-US" dirty="0"/>
+              <a:t>Utilize the </a:t>
+            </a:r>
+            <a:r>
+              <a:rPr lang="en-US" dirty="0" err="1"/>
+              <a:t>os</a:t>
+            </a:r>
+            <a:r>
+              <a:rPr lang="en-US" dirty="0"/>
+              <a:t> and </a:t>
+            </a:r>
+            <a:r>
+              <a:rPr lang="en-US" dirty="0" err="1"/>
+              <a:t>pathlib.Path</a:t>
+            </a:r>
+            <a:r>
+              <a:rPr lang="en-US" dirty="0"/>
+              <a:t> modules to navigate a filesystem</a:t>
+            </a:r>
+          </a:p>
+          <a:p>
+            <a:pPr marL="457200" indent="-457200">
+              <a:buFont typeface="Arial" panose="020B0604020202020204" pitchFamily="34" charset="0"/>
+              <a:buChar char="•"/>
+            </a:pPr>
+            <a:r>
+              <a:rPr lang="en-US" dirty="0"/>
+              <a:t>Utilize standard python functions to manipulate files</a:t>
+            </a:r>
+          </a:p>
+        </p:txBody>
+      </p:sp>
+    </p:spTree>
+    <p:extLst>
+      <p:ext uri="{BB962C8B-B14F-4D97-AF65-F5344CB8AC3E}">
+        <p14:creationId xmlns:p14="http://schemas.microsoft.com/office/powerpoint/2010/main" val="3616642083"/>
+      </p:ext>
+    </p:extLst>
+  </p:cSld>
+  <p:clrMapOvr>
+    <a:masterClrMapping/>
+  </p:clrMapOvr>
+</p:sld>
+</file>
+
+<file path=ppt/slides/slide13.xml><?xml version="1.0" encoding="utf-8"?>
+<p:sld xmlns:a="http://schemas.openxmlformats.org/drawingml/2006/main" xmlns:r="http://schemas.openxmlformats.org/officeDocument/2006/relationships" xmlns:p="http://schemas.openxmlformats.org/presentationml/2006/main">
+  <p:cSld>
+    <p:spTree>
+      <p:nvGrpSpPr>
+        <p:cNvPr id="1" name=""/>
+        <p:cNvGrpSpPr/>
+        <p:nvPr/>
+      </p:nvGrpSpPr>
+      <p:grpSpPr>
+        <a:xfrm>
+          <a:off x="0" y="0"/>
+          <a:ext cx="0" cy="0"/>
+          <a:chOff x="0" y="0"/>
+          <a:chExt cx="0" cy="0"/>
+        </a:xfrm>
+      </p:grpSpPr>
+      <p:sp>
+        <p:nvSpPr>
+          <p:cNvPr id="5" name="Title 4">
+            <a:extLst>
+              <a:ext uri="{FF2B5EF4-FFF2-40B4-BE49-F238E27FC236}">
+                <a16:creationId xmlns:a16="http://schemas.microsoft.com/office/drawing/2014/main" id="{C09D6BAA-9655-19E9-C6CF-82D4EC658E94}"/>
+              </a:ext>
+            </a:extLst>
+          </p:cNvPr>
+          <p:cNvSpPr>
+            <a:spLocks noGrp="1"/>
+          </p:cNvSpPr>
+          <p:nvPr>
+            <p:ph type="title"/>
+          </p:nvPr>
+        </p:nvSpPr>
+        <p:spPr/>
+        <p:txBody>
+          <a:bodyPr/>
+          <a:lstStyle/>
+          <a:p>
+            <a:r>
+              <a:rPr lang="en-US" dirty="0"/>
+              <a:t>OS module</a:t>
+            </a:r>
+          </a:p>
+        </p:txBody>
+      </p:sp>
+      <p:sp>
+        <p:nvSpPr>
+          <p:cNvPr id="3" name="TextBox 2">
+            <a:extLst>
+              <a:ext uri="{FF2B5EF4-FFF2-40B4-BE49-F238E27FC236}">
+                <a16:creationId xmlns:a16="http://schemas.microsoft.com/office/drawing/2014/main" id="{CBEAAC7B-2455-0DE6-A3BC-5EE8916C5C2B}"/>
+              </a:ext>
+            </a:extLst>
+          </p:cNvPr>
+          <p:cNvSpPr txBox="1"/>
+          <p:nvPr/>
+        </p:nvSpPr>
+        <p:spPr>
+          <a:xfrm>
+            <a:off x="1568919" y="2644170"/>
+            <a:ext cx="9452008" cy="1569660"/>
+          </a:xfrm>
+          <a:prstGeom prst="rect">
+            <a:avLst/>
+          </a:prstGeom>
+          <a:noFill/>
+        </p:spPr>
+        <p:txBody>
+          <a:bodyPr wrap="square">
+            <a:spAutoFit/>
+          </a:bodyPr>
+          <a:lstStyle/>
+          <a:p>
+            <a:pPr>
+              <a:buNone/>
+            </a:pPr>
+            <a:r>
+              <a:rPr lang="en-US" sz="2400" dirty="0">
+                <a:effectLst/>
+              </a:rPr>
+              <a:t>The </a:t>
+            </a:r>
+            <a:r>
+              <a:rPr lang="en-US" sz="2400" dirty="0" err="1">
+                <a:effectLst/>
+                <a:latin typeface="Courier New" panose="02070309020205020404" pitchFamily="49" charset="0"/>
+              </a:rPr>
+              <a:t>os</a:t>
+            </a:r>
+            <a:r>
+              <a:rPr lang="en-US" sz="2400" dirty="0">
+                <a:effectLst/>
+              </a:rPr>
+              <a:t> module in Python provides a way to interact with the operating system. It offers a portable interface for OS-dependent functionality, meaning your code can work across different platforms (Windows, macOS, Linux) without major changes.</a:t>
+            </a:r>
+          </a:p>
+        </p:txBody>
+      </p:sp>
+    </p:spTree>
+    <p:extLst>
+      <p:ext uri="{BB962C8B-B14F-4D97-AF65-F5344CB8AC3E}">
+        <p14:creationId xmlns:p14="http://schemas.microsoft.com/office/powerpoint/2010/main" val="3047554373"/>
+      </p:ext>
+    </p:extLst>
+  </p:cSld>
+  <p:clrMapOvr>
+    <a:masterClrMapping/>
+  </p:clrMapOvr>
+</p:sld>
+</file>
+
+<file path=ppt/slides/slide14.xml><?xml version="1.0" encoding="utf-8"?>
 <p:sld xmlns:a="http://schemas.openxmlformats.org/drawingml/2006/main" xmlns:r="http://schemas.openxmlformats.org/officeDocument/2006/relationships" xmlns:p="http://schemas.openxmlformats.org/presentationml/2006/main">
   <p:cSld>
     <p:spTree>
@@ -45657,7 +47730,7 @@
 </p:sld>
 </file>
 
-<file path=ppt/slides/slide11.xml><?xml version="1.0" encoding="utf-8"?>
+<file path=ppt/slides/slide15.xml><?xml version="1.0" encoding="utf-8"?>
 <p:sld xmlns:a="http://schemas.openxmlformats.org/drawingml/2006/main" xmlns:r="http://schemas.openxmlformats.org/officeDocument/2006/relationships" xmlns:p="http://schemas.openxmlformats.org/presentationml/2006/main">
   <p:cSld>
     <p:spTree>
@@ -46422,7 +48495,7 @@
 </p:sld>
 </file>
 
-<file path=ppt/slides/slide12.xml><?xml version="1.0" encoding="utf-8"?>
+<file path=ppt/slides/slide16.xml><?xml version="1.0" encoding="utf-8"?>
 <p:sld xmlns:a="http://schemas.openxmlformats.org/drawingml/2006/main" xmlns:r="http://schemas.openxmlformats.org/officeDocument/2006/relationships" xmlns:p="http://schemas.openxmlformats.org/presentationml/2006/main">
   <p:cSld>
     <p:spTree>
@@ -46675,7 +48748,7 @@
 </p:sld>
 </file>
 
-<file path=ppt/slides/slide13.xml><?xml version="1.0" encoding="utf-8"?>
+<file path=ppt/slides/slide17.xml><?xml version="1.0" encoding="utf-8"?>
 <p:sld xmlns:a="http://schemas.openxmlformats.org/drawingml/2006/main" xmlns:r="http://schemas.openxmlformats.org/officeDocument/2006/relationships" xmlns:p="http://schemas.openxmlformats.org/presentationml/2006/main">
   <p:cSld>
     <p:spTree>
@@ -47637,7 +49710,7 @@
 </p:sld>
 </file>
 
-<file path=ppt/slides/slide14.xml><?xml version="1.0" encoding="utf-8"?>
+<file path=ppt/slides/slide18.xml><?xml version="1.0" encoding="utf-8"?>
 <p:sld xmlns:a="http://schemas.openxmlformats.org/drawingml/2006/main" xmlns:r="http://schemas.openxmlformats.org/officeDocument/2006/relationships" xmlns:p="http://schemas.openxmlformats.org/presentationml/2006/main">
   <p:cSld>
     <p:spTree>
@@ -49033,7 +51106,7 @@
 </p:sld>
 </file>
 
-<file path=ppt/slides/slide15.xml><?xml version="1.0" encoding="utf-8"?>
+<file path=ppt/slides/slide19.xml><?xml version="1.0" encoding="utf-8"?>
 <p:sld xmlns:a="http://schemas.openxmlformats.org/drawingml/2006/main" xmlns:r="http://schemas.openxmlformats.org/officeDocument/2006/relationships" xmlns:p="http://schemas.openxmlformats.org/presentationml/2006/main">
   <p:cSld>
     <p:spTree>
@@ -49981,7 +52054,242 @@
 </p:sld>
 </file>
 
-<file path=ppt/slides/slide16.xml><?xml version="1.0" encoding="utf-8"?>
+<file path=ppt/slides/slide2.xml><?xml version="1.0" encoding="utf-8"?>
+<p:sld xmlns:a="http://schemas.openxmlformats.org/drawingml/2006/main" xmlns:r="http://schemas.openxmlformats.org/officeDocument/2006/relationships" xmlns:p="http://schemas.openxmlformats.org/presentationml/2006/main">
+  <p:cSld>
+    <p:spTree>
+      <p:nvGrpSpPr>
+        <p:cNvPr id="1" name="">
+          <a:extLst>
+            <a:ext uri="{FF2B5EF4-FFF2-40B4-BE49-F238E27FC236}">
+              <a16:creationId xmlns:a16="http://schemas.microsoft.com/office/drawing/2014/main" id="{5B19D20E-BD9A-847F-707A-41F7A86C8D39}"/>
+            </a:ext>
+          </a:extLst>
+        </p:cNvPr>
+        <p:cNvGrpSpPr/>
+        <p:nvPr/>
+      </p:nvGrpSpPr>
+      <p:grpSpPr>
+        <a:xfrm>
+          <a:off x="0" y="0"/>
+          <a:ext cx="0" cy="0"/>
+          <a:chOff x="0" y="0"/>
+          <a:chExt cx="0" cy="0"/>
+        </a:xfrm>
+      </p:grpSpPr>
+      <p:sp>
+        <p:nvSpPr>
+          <p:cNvPr id="2" name="Title 1">
+            <a:extLst>
+              <a:ext uri="{FF2B5EF4-FFF2-40B4-BE49-F238E27FC236}">
+                <a16:creationId xmlns:a16="http://schemas.microsoft.com/office/drawing/2014/main" id="{DC869BD9-8066-F6DB-BC59-621195265012}"/>
+              </a:ext>
+            </a:extLst>
+          </p:cNvPr>
+          <p:cNvSpPr>
+            <a:spLocks noGrp="1"/>
+          </p:cNvSpPr>
+          <p:nvPr>
+            <p:ph type="title"/>
+          </p:nvPr>
+        </p:nvSpPr>
+        <p:spPr/>
+        <p:txBody>
+          <a:bodyPr/>
+          <a:lstStyle/>
+          <a:p>
+            <a:br>
+              <a:rPr lang="en-US" dirty="0"/>
+            </a:br>
+            <a:r>
+              <a:rPr lang="en-US" dirty="0"/>
+              <a:t>Motivation</a:t>
+            </a:r>
+          </a:p>
+        </p:txBody>
+      </p:sp>
+      <p:pic>
+        <p:nvPicPr>
+          <p:cNvPr id="5" name="Online Media 4" title="Shia LaBeouf &quot;Just Do It&quot; Motivational Speech (Original Video by LaBeouf, Rönkkö &amp; Turner)">
+            <a:hlinkClick r:id="" action="ppaction://media"/>
+            <a:extLst>
+              <a:ext uri="{FF2B5EF4-FFF2-40B4-BE49-F238E27FC236}">
+                <a16:creationId xmlns:a16="http://schemas.microsoft.com/office/drawing/2014/main" id="{F897A0C9-F5F4-E02C-08D8-BD4BFD254FF8}"/>
+              </a:ext>
+            </a:extLst>
+          </p:cNvPr>
+          <p:cNvPicPr>
+            <a:picLocks noRot="1" noChangeAspect="1"/>
+          </p:cNvPicPr>
+          <p:nvPr>
+            <a:videoFile r:link="rId1"/>
+          </p:nvPr>
+        </p:nvPicPr>
+        <p:blipFill>
+          <a:blip r:embed="rId4"/>
+          <a:stretch>
+            <a:fillRect/>
+          </a:stretch>
+        </p:blipFill>
+        <p:spPr>
+          <a:xfrm>
+            <a:off x="1799923" y="1555719"/>
+            <a:ext cx="8162224" cy="4611667"/>
+          </a:xfrm>
+          <a:prstGeom prst="rect">
+            <a:avLst/>
+          </a:prstGeom>
+        </p:spPr>
+      </p:pic>
+    </p:spTree>
+    <p:extLst>
+      <p:ext uri="{BB962C8B-B14F-4D97-AF65-F5344CB8AC3E}">
+        <p14:creationId xmlns:p14="http://schemas.microsoft.com/office/powerpoint/2010/main" val="2254684427"/>
+      </p:ext>
+    </p:extLst>
+  </p:cSld>
+  <p:clrMapOvr>
+    <a:masterClrMapping/>
+  </p:clrMapOvr>
+  <p:timing>
+    <p:tnLst>
+      <p:par>
+        <p:cTn id="1" dur="indefinite" restart="never" nodeType="tmRoot">
+          <p:childTnLst>
+            <p:seq concurrent="1" nextAc="seek">
+              <p:cTn id="2" dur="indefinite" nodeType="mainSeq">
+                <p:childTnLst>
+                  <p:par>
+                    <p:cTn id="3" fill="hold">
+                      <p:stCondLst>
+                        <p:cond delay="indefinite"/>
+                      </p:stCondLst>
+                      <p:childTnLst>
+                        <p:par>
+                          <p:cTn id="4" fill="hold">
+                            <p:stCondLst>
+                              <p:cond delay="0"/>
+                            </p:stCondLst>
+                            <p:childTnLst>
+                              <p:par>
+                                <p:cTn id="5" presetID="1" presetClass="mediacall" presetSubtype="0" fill="hold" nodeType="clickEffect">
+                                  <p:stCondLst>
+                                    <p:cond delay="0"/>
+                                  </p:stCondLst>
+                                  <p:childTnLst>
+                                    <p:cmd type="call" cmd="playFrom(0.0)">
+                                      <p:cBhvr>
+                                        <p:cTn id="6" dur="1" fill="hold"/>
+                                        <p:tgtEl>
+                                          <p:spTgt spid="5"/>
+                                        </p:tgtEl>
+                                      </p:cBhvr>
+                                    </p:cmd>
+                                  </p:childTnLst>
+                                </p:cTn>
+                              </p:par>
+                            </p:childTnLst>
+                          </p:cTn>
+                        </p:par>
+                      </p:childTnLst>
+                    </p:cTn>
+                  </p:par>
+                </p:childTnLst>
+              </p:cTn>
+              <p:prevCondLst>
+                <p:cond evt="onPrev" delay="0">
+                  <p:tgtEl>
+                    <p:sldTgt/>
+                  </p:tgtEl>
+                </p:cond>
+              </p:prevCondLst>
+              <p:nextCondLst>
+                <p:cond evt="onNext" delay="0">
+                  <p:tgtEl>
+                    <p:sldTgt/>
+                  </p:tgtEl>
+                </p:cond>
+              </p:nextCondLst>
+            </p:seq>
+            <p:video>
+              <p:cMediaNode vol="80000">
+                <p:cTn id="7" fill="hold" display="0">
+                  <p:stCondLst>
+                    <p:cond delay="indefinite"/>
+                  </p:stCondLst>
+                </p:cTn>
+                <p:tgtEl>
+                  <p:spTgt spid="5"/>
+                </p:tgtEl>
+              </p:cMediaNode>
+            </p:video>
+            <p:seq concurrent="1" nextAc="seek">
+              <p:cTn id="8" restart="whenNotActive" fill="hold" evtFilter="cancelBubble" nodeType="interactiveSeq">
+                <p:stCondLst>
+                  <p:cond evt="onClick" delay="0">
+                    <p:tgtEl>
+                      <p:spTgt spid="5"/>
+                    </p:tgtEl>
+                  </p:cond>
+                </p:stCondLst>
+                <p:endSync evt="end" delay="0">
+                  <p:rtn val="all"/>
+                </p:endSync>
+                <p:childTnLst>
+                  <p:par>
+                    <p:cTn id="9" fill="hold">
+                      <p:stCondLst>
+                        <p:cond delay="0"/>
+                      </p:stCondLst>
+                      <p:childTnLst>
+                        <p:par>
+                          <p:cTn id="10" fill="hold">
+                            <p:stCondLst>
+                              <p:cond delay="0"/>
+                            </p:stCondLst>
+                            <p:childTnLst>
+                              <p:par>
+                                <p:cTn id="11" presetID="2" presetClass="mediacall" presetSubtype="0" fill="hold" nodeType="clickEffect">
+                                  <p:stCondLst>
+                                    <p:cond delay="0"/>
+                                  </p:stCondLst>
+                                  <p:childTnLst>
+                                    <p:cmd type="call" cmd="togglePause">
+                                      <p:cBhvr>
+                                        <p:cTn id="12" dur="1" fill="hold"/>
+                                        <p:tgtEl>
+                                          <p:spTgt spid="5"/>
+                                        </p:tgtEl>
+                                      </p:cBhvr>
+                                    </p:cmd>
+                                  </p:childTnLst>
+                                </p:cTn>
+                              </p:par>
+                            </p:childTnLst>
+                          </p:cTn>
+                        </p:par>
+                      </p:childTnLst>
+                    </p:cTn>
+                  </p:par>
+                </p:childTnLst>
+              </p:cTn>
+              <p:nextCondLst>
+                <p:cond evt="onClick" delay="0">
+                  <p:tgtEl>
+                    <p:spTgt spid="5"/>
+                  </p:tgtEl>
+                </p:cond>
+              </p:nextCondLst>
+            </p:seq>
+          </p:childTnLst>
+        </p:cTn>
+      </p:par>
+    </p:tnLst>
+  </p:timing>
+</p:sld>
+</file>
+
+<file path=ppt/slides/slide20.xml><?xml version="1.0" encoding="utf-8"?>
 <p:sld xmlns:a="http://schemas.openxmlformats.org/drawingml/2006/main" xmlns:r="http://schemas.openxmlformats.org/officeDocument/2006/relationships" xmlns:p="http://schemas.openxmlformats.org/presentationml/2006/main">
   <p:cSld>
     <p:spTree>
@@ -51045,7 +53353,7 @@
 </p:sld>
 </file>
 
-<file path=ppt/slides/slide17.xml><?xml version="1.0" encoding="utf-8"?>
+<file path=ppt/slides/slide21.xml><?xml version="1.0" encoding="utf-8"?>
 <p:sld xmlns:a="http://schemas.openxmlformats.org/drawingml/2006/main" xmlns:r="http://schemas.openxmlformats.org/officeDocument/2006/relationships" xmlns:p="http://schemas.openxmlformats.org/presentationml/2006/main">
   <p:cSld>
     <p:spTree>
@@ -51134,7 +53442,7 @@
 </p:sld>
 </file>
 
-<file path=ppt/slides/slide18.xml><?xml version="1.0" encoding="utf-8"?>
+<file path=ppt/slides/slide22.xml><?xml version="1.0" encoding="utf-8"?>
 <p:sld xmlns:a="http://schemas.openxmlformats.org/drawingml/2006/main" xmlns:r="http://schemas.openxmlformats.org/officeDocument/2006/relationships" xmlns:p="http://schemas.openxmlformats.org/presentationml/2006/main">
   <p:cSld>
     <p:spTree>
@@ -51246,7 +53554,7 @@
 </p:sld>
 </file>
 
-<file path=ppt/slides/slide19.xml><?xml version="1.0" encoding="utf-8"?>
+<file path=ppt/slides/slide23.xml><?xml version="1.0" encoding="utf-8"?>
 <p:sld xmlns:a="http://schemas.openxmlformats.org/drawingml/2006/main" xmlns:r="http://schemas.openxmlformats.org/officeDocument/2006/relationships" xmlns:p="http://schemas.openxmlformats.org/presentationml/2006/main">
   <p:cSld>
     <p:spTree>
@@ -52053,74 +54361,7 @@
 </p:sld>
 </file>
 
-<file path=ppt/slides/slide2.xml><?xml version="1.0" encoding="utf-8"?>
-<p:sld xmlns:a="http://schemas.openxmlformats.org/drawingml/2006/main" xmlns:r="http://schemas.openxmlformats.org/officeDocument/2006/relationships" xmlns:p="http://schemas.openxmlformats.org/presentationml/2006/main">
-  <p:cSld>
-    <p:spTree>
-      <p:nvGrpSpPr>
-        <p:cNvPr id="1" name="">
-          <a:extLst>
-            <a:ext uri="{FF2B5EF4-FFF2-40B4-BE49-F238E27FC236}">
-              <a16:creationId xmlns:a16="http://schemas.microsoft.com/office/drawing/2014/main" id="{5B19D20E-BD9A-847F-707A-41F7A86C8D39}"/>
-            </a:ext>
-          </a:extLst>
-        </p:cNvPr>
-        <p:cNvGrpSpPr/>
-        <p:nvPr/>
-      </p:nvGrpSpPr>
-      <p:grpSpPr>
-        <a:xfrm>
-          <a:off x="0" y="0"/>
-          <a:ext cx="0" cy="0"/>
-          <a:chOff x="0" y="0"/>
-          <a:chExt cx="0" cy="0"/>
-        </a:xfrm>
-      </p:grpSpPr>
-      <p:sp>
-        <p:nvSpPr>
-          <p:cNvPr id="2" name="Title 1">
-            <a:extLst>
-              <a:ext uri="{FF2B5EF4-FFF2-40B4-BE49-F238E27FC236}">
-                <a16:creationId xmlns:a16="http://schemas.microsoft.com/office/drawing/2014/main" id="{DC869BD9-8066-F6DB-BC59-621195265012}"/>
-              </a:ext>
-            </a:extLst>
-          </p:cNvPr>
-          <p:cNvSpPr>
-            <a:spLocks noGrp="1"/>
-          </p:cNvSpPr>
-          <p:nvPr>
-            <p:ph type="title"/>
-          </p:nvPr>
-        </p:nvSpPr>
-        <p:spPr/>
-        <p:txBody>
-          <a:bodyPr/>
-          <a:lstStyle/>
-          <a:p>
-            <a:br>
-              <a:rPr lang="en-US" dirty="0"/>
-            </a:br>
-            <a:r>
-              <a:rPr lang="en-US" dirty="0"/>
-              <a:t>Motivation</a:t>
-            </a:r>
-          </a:p>
-        </p:txBody>
-      </p:sp>
-    </p:spTree>
-    <p:extLst>
-      <p:ext uri="{BB962C8B-B14F-4D97-AF65-F5344CB8AC3E}">
-        <p14:creationId xmlns:p14="http://schemas.microsoft.com/office/powerpoint/2010/main" val="2254684427"/>
-      </p:ext>
-    </p:extLst>
-  </p:cSld>
-  <p:clrMapOvr>
-    <a:masterClrMapping/>
-  </p:clrMapOvr>
-</p:sld>
-</file>
-
-<file path=ppt/slides/slide20.xml><?xml version="1.0" encoding="utf-8"?>
+<file path=ppt/slides/slide24.xml><?xml version="1.0" encoding="utf-8"?>
 <p:sld xmlns:a="http://schemas.openxmlformats.org/drawingml/2006/main" xmlns:r="http://schemas.openxmlformats.org/officeDocument/2006/relationships" xmlns:p="http://schemas.openxmlformats.org/presentationml/2006/main">
   <p:cSld>
     <p:spTree>
@@ -52236,7 +54477,7 @@
 </p:sld>
 </file>
 
-<file path=ppt/slides/slide21.xml><?xml version="1.0" encoding="utf-8"?>
+<file path=ppt/slides/slide25.xml><?xml version="1.0" encoding="utf-8"?>
 <p:sld xmlns:a="http://schemas.openxmlformats.org/drawingml/2006/main" xmlns:r="http://schemas.openxmlformats.org/officeDocument/2006/relationships" xmlns:p="http://schemas.openxmlformats.org/presentationml/2006/main">
   <p:cSld>
     <p:spTree>
@@ -52323,7 +54564,7 @@
 </p:sld>
 </file>
 
-<file path=ppt/slides/slide22.xml><?xml version="1.0" encoding="utf-8"?>
+<file path=ppt/slides/slide26.xml><?xml version="1.0" encoding="utf-8"?>
 <p:sld xmlns:a="http://schemas.openxmlformats.org/drawingml/2006/main" xmlns:r="http://schemas.openxmlformats.org/officeDocument/2006/relationships" xmlns:p="http://schemas.openxmlformats.org/presentationml/2006/main">
   <p:cSld>
     <p:spTree>
@@ -52409,7 +54650,7 @@
 </p:sld>
 </file>
 
-<file path=ppt/slides/slide23.xml><?xml version="1.0" encoding="utf-8"?>
+<file path=ppt/slides/slide27.xml><?xml version="1.0" encoding="utf-8"?>
 <p:sld xmlns:a="http://schemas.openxmlformats.org/drawingml/2006/main" xmlns:r="http://schemas.openxmlformats.org/officeDocument/2006/relationships" xmlns:p="http://schemas.openxmlformats.org/presentationml/2006/main">
   <p:cSld>
     <p:spTree>
@@ -52949,13 +55190,7 @@
   <p:cSld>
     <p:spTree>
       <p:nvGrpSpPr>
-        <p:cNvPr id="1" name="">
-          <a:extLst>
-            <a:ext uri="{FF2B5EF4-FFF2-40B4-BE49-F238E27FC236}">
-              <a16:creationId xmlns:a16="http://schemas.microsoft.com/office/drawing/2014/main" id="{F0C5B1A7-8E0E-589E-EB86-60B4773E061F}"/>
-            </a:ext>
-          </a:extLst>
-        </p:cNvPr>
+        <p:cNvPr id="1" name="Shape 58"/>
         <p:cNvGrpSpPr/>
         <p:nvPr/>
       </p:nvGrpSpPr>
@@ -52969,570 +55204,163 @@
       </p:grpSpPr>
       <p:sp>
         <p:nvSpPr>
-          <p:cNvPr id="2" name="Title 1">
-            <a:extLst>
-              <a:ext uri="{FF2B5EF4-FFF2-40B4-BE49-F238E27FC236}">
-                <a16:creationId xmlns:a16="http://schemas.microsoft.com/office/drawing/2014/main" id="{5F1A3DAE-54C2-F616-33A3-63FF6D72FBE3}"/>
-              </a:ext>
-            </a:extLst>
-          </p:cNvPr>
-          <p:cNvSpPr>
+          <p:cNvPr id="59" name="Google Shape;59;p14"/>
+          <p:cNvSpPr txBox="1">
             <a:spLocks noGrp="1"/>
           </p:cNvSpPr>
           <p:nvPr>
-            <p:ph type="title"/>
+            <p:ph type="body" idx="1"/>
           </p:nvPr>
         </p:nvSpPr>
         <p:spPr>
           <a:xfrm>
-            <a:off x="2793283" y="1181186"/>
-            <a:ext cx="7053360" cy="780276"/>
-          </a:xfrm>
-        </p:spPr>
-        <p:txBody>
-          <a:bodyPr/>
-          <a:lstStyle/>
-          <a:p>
-            <a:r>
-              <a:rPr lang="en-US" dirty="0"/>
-              <a:t>Let’s make this a function:</a:t>
-            </a:r>
-          </a:p>
-        </p:txBody>
-      </p:sp>
-      <p:pic>
-        <p:nvPicPr>
-          <p:cNvPr id="3" name="Picture 2" descr="The compound interest formula: A = P(1 + r/n)^nt">
-            <a:extLst>
-              <a:ext uri="{FF2B5EF4-FFF2-40B4-BE49-F238E27FC236}">
-                <a16:creationId xmlns:a16="http://schemas.microsoft.com/office/drawing/2014/main" id="{28EB7F59-C3C8-A0C1-2E1A-91BCEE397C42}"/>
-              </a:ext>
-            </a:extLst>
-          </p:cNvPr>
-          <p:cNvPicPr>
-            <a:picLocks noChangeAspect="1"/>
-          </p:cNvPicPr>
-          <p:nvPr/>
-        </p:nvPicPr>
-        <p:blipFill>
-          <a:blip r:embed="rId3"/>
-          <a:stretch>
-            <a:fillRect/>
-          </a:stretch>
-        </p:blipFill>
-        <p:spPr>
-          <a:xfrm>
-            <a:off x="3704565" y="1851046"/>
-            <a:ext cx="3956700" cy="2154880"/>
+            <a:off x="338598" y="534400"/>
+            <a:ext cx="11360800" cy="6323600"/>
           </a:xfrm>
           <a:prstGeom prst="rect">
             <a:avLst/>
           </a:prstGeom>
         </p:spPr>
-      </p:pic>
-      <p:graphicFrame>
-        <p:nvGraphicFramePr>
-          <p:cNvPr id="4" name="Table 3">
-            <a:extLst>
-              <a:ext uri="{FF2B5EF4-FFF2-40B4-BE49-F238E27FC236}">
-                <a16:creationId xmlns:a16="http://schemas.microsoft.com/office/drawing/2014/main" id="{09D2CF20-5FF3-CF01-AD9F-9B2D15DA2168}"/>
-              </a:ext>
-            </a:extLst>
-          </p:cNvPr>
-          <p:cNvGraphicFramePr>
-            <a:graphicFrameLocks noGrp="1"/>
-          </p:cNvGraphicFramePr>
-          <p:nvPr>
-            <p:extLst>
-              <p:ext uri="{D42A27DB-BD31-4B8C-83A1-F6EECF244321}">
-                <p14:modId xmlns:p14="http://schemas.microsoft.com/office/powerpoint/2010/main" val="1262173274"/>
-              </p:ext>
-            </p:extLst>
-          </p:nvPr>
-        </p:nvGraphicFramePr>
-        <p:xfrm>
-          <a:off x="423511" y="4153514"/>
-          <a:ext cx="10518809" cy="2438400"/>
-        </p:xfrm>
-        <a:graphic>
-          <a:graphicData uri="http://schemas.openxmlformats.org/drawingml/2006/table">
-            <a:tbl>
-              <a:tblPr firstRow="1" bandRow="1">
-                <a:tableStyleId>{5C22544A-7EE6-4342-B048-85BDC9FD1C3A}</a:tableStyleId>
-              </a:tblPr>
-              <a:tblGrid>
-                <a:gridCol w="1753135">
-                  <a:extLst>
-                    <a:ext uri="{9D8B030D-6E8A-4147-A177-3AD203B41FA5}">
-                      <a16:colId xmlns:a16="http://schemas.microsoft.com/office/drawing/2014/main" val="1599770990"/>
-                    </a:ext>
-                  </a:extLst>
-                </a:gridCol>
-                <a:gridCol w="1753135">
-                  <a:extLst>
-                    <a:ext uri="{9D8B030D-6E8A-4147-A177-3AD203B41FA5}">
-                      <a16:colId xmlns:a16="http://schemas.microsoft.com/office/drawing/2014/main" val="2076677805"/>
-                    </a:ext>
-                  </a:extLst>
-                </a:gridCol>
-                <a:gridCol w="1753135">
-                  <a:extLst>
-                    <a:ext uri="{9D8B030D-6E8A-4147-A177-3AD203B41FA5}">
-                      <a16:colId xmlns:a16="http://schemas.microsoft.com/office/drawing/2014/main" val="4293853211"/>
-                    </a:ext>
-                  </a:extLst>
-                </a:gridCol>
-                <a:gridCol w="1992087">
-                  <a:extLst>
-                    <a:ext uri="{9D8B030D-6E8A-4147-A177-3AD203B41FA5}">
-                      <a16:colId xmlns:a16="http://schemas.microsoft.com/office/drawing/2014/main" val="2141661481"/>
-                    </a:ext>
-                  </a:extLst>
-                </a:gridCol>
-                <a:gridCol w="1514182">
-                  <a:extLst>
-                    <a:ext uri="{9D8B030D-6E8A-4147-A177-3AD203B41FA5}">
-                      <a16:colId xmlns:a16="http://schemas.microsoft.com/office/drawing/2014/main" val="1863223125"/>
-                    </a:ext>
-                  </a:extLst>
-                </a:gridCol>
-                <a:gridCol w="1753135">
-                  <a:extLst>
-                    <a:ext uri="{9D8B030D-6E8A-4147-A177-3AD203B41FA5}">
-                      <a16:colId xmlns:a16="http://schemas.microsoft.com/office/drawing/2014/main" val="2610029996"/>
-                    </a:ext>
-                  </a:extLst>
-                </a:gridCol>
-              </a:tblGrid>
-              <a:tr h="269217">
-                <a:tc>
-                  <a:txBody>
-                    <a:bodyPr/>
-                    <a:lstStyle/>
-                    <a:p>
-                      <a:r>
-                        <a:rPr lang="en-US" dirty="0"/>
-                        <a:t>Desc.</a:t>
-                      </a:r>
-                    </a:p>
-                  </a:txBody>
-                  <a:tcPr/>
-                </a:tc>
-                <a:tc>
-                  <a:txBody>
-                    <a:bodyPr/>
-                    <a:lstStyle/>
-                    <a:p>
-                      <a:r>
-                        <a:rPr lang="en-US" dirty="0"/>
-                        <a:t>Principal</a:t>
-                      </a:r>
-                    </a:p>
-                  </a:txBody>
-                  <a:tcPr/>
-                </a:tc>
-                <a:tc>
-                  <a:txBody>
-                    <a:bodyPr/>
-                    <a:lstStyle/>
-                    <a:p>
-                      <a:r>
-                        <a:rPr lang="en-US" dirty="0"/>
-                        <a:t>Rate</a:t>
-                      </a:r>
-                    </a:p>
-                  </a:txBody>
-                  <a:tcPr/>
-                </a:tc>
-                <a:tc>
-                  <a:txBody>
-                    <a:bodyPr/>
-                    <a:lstStyle/>
-                    <a:p>
-                      <a:r>
-                        <a:rPr lang="en-US" dirty="0"/>
-                        <a:t># of times compounded annually</a:t>
-                      </a:r>
-                    </a:p>
-                  </a:txBody>
-                  <a:tcPr/>
-                </a:tc>
-                <a:tc>
-                  <a:txBody>
-                    <a:bodyPr/>
-                    <a:lstStyle/>
-                    <a:p>
-                      <a:r>
-                        <a:rPr lang="en-US" dirty="0"/>
-                        <a:t>Years</a:t>
-                      </a:r>
-                    </a:p>
-                  </a:txBody>
-                  <a:tcPr/>
-                </a:tc>
-                <a:tc>
-                  <a:txBody>
-                    <a:bodyPr/>
-                    <a:lstStyle/>
-                    <a:p>
-                      <a:r>
-                        <a:rPr lang="en-US" dirty="0"/>
-                        <a:t>Output</a:t>
-                      </a:r>
-                    </a:p>
-                  </a:txBody>
-                  <a:tcPr/>
-                </a:tc>
-                <a:extLst>
-                  <a:ext uri="{0D108BD9-81ED-4DB2-BD59-A6C34878D82A}">
-                    <a16:rowId xmlns:a16="http://schemas.microsoft.com/office/drawing/2014/main" val="3444101573"/>
-                  </a:ext>
-                </a:extLst>
-              </a:tr>
-              <a:tr h="269217">
-                <a:tc>
-                  <a:txBody>
-                    <a:bodyPr/>
-                    <a:lstStyle/>
-                    <a:p>
-                      <a:r>
-                        <a:rPr lang="en-US" dirty="0"/>
-                        <a:t>Normal Savings Account</a:t>
-                      </a:r>
-                    </a:p>
-                  </a:txBody>
-                  <a:tcPr/>
-                </a:tc>
-                <a:tc>
-                  <a:txBody>
-                    <a:bodyPr/>
-                    <a:lstStyle/>
-                    <a:p>
-                      <a:r>
-                        <a:rPr lang="en-US" dirty="0"/>
-                        <a:t>1000</a:t>
-                      </a:r>
-                    </a:p>
-                  </a:txBody>
-                  <a:tcPr/>
-                </a:tc>
-                <a:tc>
-                  <a:txBody>
-                    <a:bodyPr/>
-                    <a:lstStyle/>
-                    <a:p>
-                      <a:r>
-                        <a:rPr lang="en-US" dirty="0"/>
-                        <a:t>0.0061</a:t>
-                      </a:r>
-                    </a:p>
-                  </a:txBody>
-                  <a:tcPr/>
-                </a:tc>
-                <a:tc>
-                  <a:txBody>
-                    <a:bodyPr/>
-                    <a:lstStyle/>
-                    <a:p>
-                      <a:r>
-                        <a:rPr lang="en-US" dirty="0"/>
-                        <a:t>1</a:t>
-                      </a:r>
-                    </a:p>
-                  </a:txBody>
-                  <a:tcPr/>
-                </a:tc>
-                <a:tc>
-                  <a:txBody>
-                    <a:bodyPr/>
-                    <a:lstStyle/>
-                    <a:p>
-                      <a:r>
-                        <a:rPr lang="en-US" dirty="0"/>
-                        <a:t>10</a:t>
-                      </a:r>
-                    </a:p>
-                  </a:txBody>
-                  <a:tcPr/>
-                </a:tc>
-                <a:tc>
-                  <a:txBody>
-                    <a:bodyPr/>
-                    <a:lstStyle/>
-                    <a:p>
-                      <a:r>
-                        <a:rPr lang="en-US" dirty="0"/>
-                        <a:t>$1062.70</a:t>
-                      </a:r>
-                    </a:p>
-                  </a:txBody>
-                  <a:tcPr/>
-                </a:tc>
-                <a:extLst>
-                  <a:ext uri="{0D108BD9-81ED-4DB2-BD59-A6C34878D82A}">
-                    <a16:rowId xmlns:a16="http://schemas.microsoft.com/office/drawing/2014/main" val="2415867046"/>
-                  </a:ext>
-                </a:extLst>
-              </a:tr>
-              <a:tr h="269217">
-                <a:tc>
-                  <a:txBody>
-                    <a:bodyPr/>
-                    <a:lstStyle/>
-                    <a:p>
-                      <a:r>
-                        <a:rPr lang="en-US" dirty="0"/>
-                        <a:t>Money Market Account (Amex)</a:t>
-                      </a:r>
-                    </a:p>
-                  </a:txBody>
-                  <a:tcPr/>
-                </a:tc>
-                <a:tc>
-                  <a:txBody>
-                    <a:bodyPr/>
-                    <a:lstStyle/>
-                    <a:p>
-                      <a:r>
-                        <a:rPr lang="en-US" dirty="0"/>
-                        <a:t>1000</a:t>
-                      </a:r>
-                    </a:p>
-                  </a:txBody>
-                  <a:tcPr/>
-                </a:tc>
-                <a:tc>
-                  <a:txBody>
-                    <a:bodyPr/>
-                    <a:lstStyle/>
-                    <a:p>
-                      <a:r>
-                        <a:rPr lang="en-US" dirty="0"/>
-                        <a:t>0.031</a:t>
-                      </a:r>
-                    </a:p>
-                  </a:txBody>
-                  <a:tcPr/>
-                </a:tc>
-                <a:tc>
-                  <a:txBody>
-                    <a:bodyPr/>
-                    <a:lstStyle/>
-                    <a:p>
-                      <a:r>
-                        <a:rPr lang="en-US" dirty="0"/>
-                        <a:t>1</a:t>
-                      </a:r>
-                    </a:p>
-                  </a:txBody>
-                  <a:tcPr/>
-                </a:tc>
-                <a:tc>
-                  <a:txBody>
-                    <a:bodyPr/>
-                    <a:lstStyle/>
-                    <a:p>
-                      <a:r>
-                        <a:rPr lang="en-US" dirty="0"/>
-                        <a:t>10</a:t>
-                      </a:r>
-                    </a:p>
-                  </a:txBody>
-                  <a:tcPr/>
-                </a:tc>
-                <a:tc>
-                  <a:txBody>
-                    <a:bodyPr/>
-                    <a:lstStyle/>
-                    <a:p>
-                      <a:r>
-                        <a:rPr lang="en-US" dirty="0"/>
-                        <a:t>$1357.02</a:t>
-                      </a:r>
-                    </a:p>
-                  </a:txBody>
-                  <a:tcPr/>
-                </a:tc>
-                <a:extLst>
-                  <a:ext uri="{0D108BD9-81ED-4DB2-BD59-A6C34878D82A}">
-                    <a16:rowId xmlns:a16="http://schemas.microsoft.com/office/drawing/2014/main" val="3427481328"/>
-                  </a:ext>
-                </a:extLst>
-              </a:tr>
-              <a:tr h="269217">
-                <a:tc>
-                  <a:txBody>
-                    <a:bodyPr/>
-                    <a:lstStyle/>
-                    <a:p>
-                      <a:r>
-                        <a:rPr lang="en-US" dirty="0"/>
-                        <a:t>Index Fund</a:t>
-                      </a:r>
-                    </a:p>
-                  </a:txBody>
-                  <a:tcPr/>
-                </a:tc>
-                <a:tc>
-                  <a:txBody>
-                    <a:bodyPr/>
-                    <a:lstStyle/>
-                    <a:p>
-                      <a:r>
-                        <a:rPr lang="en-US" dirty="0"/>
-                        <a:t>1000</a:t>
-                      </a:r>
-                    </a:p>
-                  </a:txBody>
-                  <a:tcPr/>
-                </a:tc>
-                <a:tc>
-                  <a:txBody>
-                    <a:bodyPr/>
-                    <a:lstStyle/>
-                    <a:p>
-                      <a:r>
-                        <a:rPr lang="en-US" dirty="0"/>
-                        <a:t>0.07</a:t>
-                      </a:r>
-                    </a:p>
-                  </a:txBody>
-                  <a:tcPr/>
-                </a:tc>
-                <a:tc>
-                  <a:txBody>
-                    <a:bodyPr/>
-                    <a:lstStyle/>
-                    <a:p>
-                      <a:r>
-                        <a:rPr lang="en-US" dirty="0"/>
-                        <a:t>1</a:t>
-                      </a:r>
-                    </a:p>
-                  </a:txBody>
-                  <a:tcPr/>
-                </a:tc>
-                <a:tc>
-                  <a:txBody>
-                    <a:bodyPr/>
-                    <a:lstStyle/>
-                    <a:p>
-                      <a:r>
-                        <a:rPr lang="en-US" dirty="0"/>
-                        <a:t>10</a:t>
-                      </a:r>
-                    </a:p>
-                  </a:txBody>
-                  <a:tcPr/>
-                </a:tc>
-                <a:tc>
-                  <a:txBody>
-                    <a:bodyPr/>
-                    <a:lstStyle/>
-                    <a:p>
-                      <a:r>
-                        <a:rPr lang="en-US" dirty="0"/>
-                        <a:t>$1967.15</a:t>
-                      </a:r>
-                    </a:p>
-                  </a:txBody>
-                  <a:tcPr/>
-                </a:tc>
-                <a:extLst>
-                  <a:ext uri="{0D108BD9-81ED-4DB2-BD59-A6C34878D82A}">
-                    <a16:rowId xmlns:a16="http://schemas.microsoft.com/office/drawing/2014/main" val="3484013442"/>
-                  </a:ext>
-                </a:extLst>
-              </a:tr>
-            </a:tbl>
-          </a:graphicData>
-        </a:graphic>
-      </p:graphicFrame>
+        <p:txBody>
+          <a:bodyPr spcFirstLastPara="1" vert="horz" wrap="square" lIns="121900" tIns="121900" rIns="121900" bIns="121900" spcCol="365760" rtlCol="0" anchor="t" anchorCtr="0">
+            <a:normAutofit fontScale="70000" lnSpcReduction="20000"/>
+          </a:bodyPr>
+          <a:lstStyle/>
+          <a:p>
+            <a:pPr marL="0" indent="0">
+              <a:buNone/>
+            </a:pPr>
+            <a:r>
+              <a:rPr lang="en" sz="3333" b="1" u="sng" dirty="0"/>
+              <a:t>Pre Class Problem 1 - The ULTIMATE RPS Simulation (20 min)</a:t>
+            </a:r>
+            <a:endParaRPr sz="3333" b="1" u="sng" dirty="0"/>
+          </a:p>
+          <a:p>
+            <a:pPr marL="0" indent="0">
+              <a:spcBef>
+                <a:spcPts val="1600"/>
+              </a:spcBef>
+              <a:buNone/>
+            </a:pPr>
+            <a:r>
+              <a:rPr lang="en" sz="3333" b="1" dirty="0"/>
+              <a:t>Starting from scratch </a:t>
+            </a:r>
+            <a:r>
+              <a:rPr lang="en" sz="3333" dirty="0"/>
+              <a:t>write a python script that allows you to play rock, paper, scissors against the computer.</a:t>
+            </a:r>
+            <a:endParaRPr sz="3333" dirty="0"/>
+          </a:p>
+          <a:p>
+            <a:pPr marL="0" indent="0">
+              <a:spcBef>
+                <a:spcPts val="1600"/>
+              </a:spcBef>
+              <a:buNone/>
+            </a:pPr>
+            <a:r>
+              <a:rPr lang="en" sz="3333" i="1" dirty="0"/>
+              <a:t>However</a:t>
+            </a:r>
+            <a:r>
+              <a:rPr lang="en" sz="3333" dirty="0"/>
+              <a:t>, in this version you will ask the user how many games they want to play to determine the overall winner.  The computer has other things to do, so it will only accept playing the best of 1 to 9 games.</a:t>
+            </a:r>
+            <a:br>
+              <a:rPr lang="en" sz="3333" dirty="0"/>
+            </a:br>
+            <a:br>
+              <a:rPr lang="en" sz="3333" dirty="0"/>
+            </a:br>
+            <a:r>
+              <a:rPr lang="en" sz="3333" dirty="0"/>
+              <a:t>Example:  How many games would you like to play to determine who is the ultimate winner?  </a:t>
+            </a:r>
+            <a:br>
+              <a:rPr lang="en" sz="3333" dirty="0"/>
+            </a:br>
+            <a:br>
+              <a:rPr lang="en" sz="3333" dirty="0"/>
+            </a:br>
+            <a:r>
+              <a:rPr lang="en" sz="3333" dirty="0"/>
+              <a:t>Implied:  User input can only be an odd number from 1 to 9.  Continue to ask the user to re-enter how many games they would like to play until the user meets these criteria.  </a:t>
+            </a:r>
+            <a:endParaRPr sz="3333" dirty="0"/>
+          </a:p>
+          <a:p>
+            <a:pPr marL="0" indent="0">
+              <a:spcBef>
+                <a:spcPts val="1600"/>
+              </a:spcBef>
+              <a:buNone/>
+            </a:pPr>
+            <a:r>
+              <a:rPr lang="en" sz="3333" dirty="0"/>
+              <a:t>Also implied:  If the user wants to play the best of 3 games, and wins the first two, they do not need to play a third game.</a:t>
+            </a:r>
+            <a:endParaRPr sz="3333" dirty="0"/>
+          </a:p>
+          <a:p>
+            <a:pPr marL="0" indent="0">
+              <a:spcBef>
+                <a:spcPts val="1600"/>
+              </a:spcBef>
+              <a:buNone/>
+            </a:pPr>
+            <a:r>
+              <a:rPr lang="en" sz="3333" b="1" dirty="0"/>
+              <a:t>Bonus:  </a:t>
+            </a:r>
+            <a:r>
+              <a:rPr lang="en" sz="3333" dirty="0"/>
+              <a:t>Incorporate ASCII-ART and delays into your game to add some flare.</a:t>
+            </a:r>
+            <a:endParaRPr sz="3333" dirty="0"/>
+          </a:p>
+          <a:p>
+            <a:pPr marL="0" indent="0">
+              <a:spcBef>
+                <a:spcPts val="1600"/>
+              </a:spcBef>
+              <a:buNone/>
+            </a:pPr>
+            <a:r>
+              <a:rPr lang="en" sz="3333" b="1" u="sng" dirty="0"/>
+              <a:t>DO NOT USE GENERATIVE AI – PUSH YOURSELF TO FIGURE THIS OUT</a:t>
+            </a:r>
+            <a:endParaRPr sz="3333" b="1" u="sng" dirty="0"/>
+          </a:p>
+          <a:p>
+            <a:pPr marL="0" indent="0">
+              <a:spcBef>
+                <a:spcPts val="1600"/>
+              </a:spcBef>
+              <a:buNone/>
+            </a:pPr>
+            <a:endParaRPr dirty="0"/>
+          </a:p>
+          <a:p>
+            <a:pPr marL="0" indent="0">
+              <a:spcBef>
+                <a:spcPts val="1600"/>
+              </a:spcBef>
+              <a:spcAft>
+                <a:spcPts val="1600"/>
+              </a:spcAft>
+              <a:buNone/>
+            </a:pPr>
+            <a:endParaRPr dirty="0"/>
+          </a:p>
+        </p:txBody>
+      </p:sp>
     </p:spTree>
-    <p:extLst>
-      <p:ext uri="{BB962C8B-B14F-4D97-AF65-F5344CB8AC3E}">
-        <p14:creationId xmlns:p14="http://schemas.microsoft.com/office/powerpoint/2010/main" val="3180408656"/>
-      </p:ext>
-    </p:extLst>
   </p:cSld>
   <p:clrMapOvr>
     <a:masterClrMapping/>
   </p:clrMapOvr>
-  <p:timing>
-    <p:tnLst>
-      <p:par>
-        <p:cTn id="1" dur="indefinite" restart="never" nodeType="tmRoot">
-          <p:childTnLst>
-            <p:seq concurrent="1" nextAc="seek">
-              <p:cTn id="2" dur="indefinite" nodeType="mainSeq">
-                <p:childTnLst>
-                  <p:par>
-                    <p:cTn id="3" fill="hold">
-                      <p:stCondLst>
-                        <p:cond delay="indefinite"/>
-                      </p:stCondLst>
-                      <p:childTnLst>
-                        <p:par>
-                          <p:cTn id="4" fill="hold">
-                            <p:stCondLst>
-                              <p:cond delay="0"/>
-                            </p:stCondLst>
-                            <p:childTnLst>
-                              <p:par>
-                                <p:cTn id="5" presetID="1" presetClass="entr" presetSubtype="0" fill="hold" nodeType="clickEffect">
-                                  <p:stCondLst>
-                                    <p:cond delay="0"/>
-                                  </p:stCondLst>
-                                  <p:childTnLst>
-                                    <p:set>
-                                      <p:cBhvr>
-                                        <p:cTn id="6" dur="1" fill="hold">
-                                          <p:stCondLst>
-                                            <p:cond delay="0"/>
-                                          </p:stCondLst>
-                                        </p:cTn>
-                                        <p:tgtEl>
-                                          <p:spTgt spid="4"/>
-                                        </p:tgtEl>
-                                        <p:attrNameLst>
-                                          <p:attrName>style.visibility</p:attrName>
-                                        </p:attrNameLst>
-                                      </p:cBhvr>
-                                      <p:to>
-                                        <p:strVal val="visible"/>
-                                      </p:to>
-                                    </p:set>
-                                  </p:childTnLst>
-                                </p:cTn>
-                              </p:par>
-                            </p:childTnLst>
-                          </p:cTn>
-                        </p:par>
-                      </p:childTnLst>
-                    </p:cTn>
-                  </p:par>
-                </p:childTnLst>
-              </p:cTn>
-              <p:prevCondLst>
-                <p:cond evt="onPrev" delay="0">
-                  <p:tgtEl>
-                    <p:sldTgt/>
-                  </p:tgtEl>
-                </p:cond>
-              </p:prevCondLst>
-              <p:nextCondLst>
-                <p:cond evt="onNext" delay="0">
-                  <p:tgtEl>
-                    <p:sldTgt/>
-                  </p:tgtEl>
-                </p:cond>
-              </p:nextCondLst>
-            </p:seq>
-          </p:childTnLst>
-        </p:cTn>
-      </p:par>
-    </p:tnLst>
-  </p:timing>
 </p:sld>
 </file>
 
@@ -53541,7 +55369,7 @@
   <p:cSld>
     <p:spTree>
       <p:nvGrpSpPr>
-        <p:cNvPr id="1" name=""/>
+        <p:cNvPr id="1" name="Shape 63"/>
         <p:cNvGrpSpPr/>
         <p:nvPr/>
       </p:nvGrpSpPr>
@@ -53555,96 +55383,422 @@
       </p:grpSpPr>
       <p:sp>
         <p:nvSpPr>
-          <p:cNvPr id="2" name="Title 1">
-            <a:extLst>
-              <a:ext uri="{FF2B5EF4-FFF2-40B4-BE49-F238E27FC236}">
-                <a16:creationId xmlns:a16="http://schemas.microsoft.com/office/drawing/2014/main" id="{57EB4430-1F71-D899-34E4-0D4105CCE823}"/>
-              </a:ext>
-            </a:extLst>
-          </p:cNvPr>
-          <p:cNvSpPr>
+          <p:cNvPr id="64" name="Google Shape;64;p15"/>
+          <p:cNvSpPr txBox="1">
             <a:spLocks noGrp="1"/>
           </p:cNvSpPr>
           <p:nvPr>
-            <p:ph type="title"/>
+            <p:ph type="body" idx="1"/>
           </p:nvPr>
         </p:nvSpPr>
-        <p:spPr/>
-        <p:txBody>
-          <a:bodyPr/>
+        <p:spPr>
+          <a:xfrm>
+            <a:off x="415600" y="284900"/>
+            <a:ext cx="11360800" cy="6323600"/>
+          </a:xfrm>
+          <a:prstGeom prst="rect">
+            <a:avLst/>
+          </a:prstGeom>
+        </p:spPr>
+        <p:txBody>
+          <a:bodyPr spcFirstLastPara="1" vert="horz" wrap="square" lIns="121900" tIns="121900" rIns="121900" bIns="121900" spcCol="365760" rtlCol="0" anchor="t" anchorCtr="0">
+            <a:normAutofit/>
+          </a:bodyPr>
           <a:lstStyle/>
           <a:p>
-            <a:r>
-              <a:rPr lang="en-US" dirty="0"/>
-              <a:t>Today’s Lesson Objectives</a:t>
-            </a:r>
-          </a:p>
-        </p:txBody>
-      </p:sp>
-      <p:sp>
-        <p:nvSpPr>
-          <p:cNvPr id="3" name="Content Placeholder 2">
-            <a:extLst>
-              <a:ext uri="{FF2B5EF4-FFF2-40B4-BE49-F238E27FC236}">
-                <a16:creationId xmlns:a16="http://schemas.microsoft.com/office/drawing/2014/main" id="{E76FF94A-3BCA-070D-C682-367F5F0F327C}"/>
-              </a:ext>
-            </a:extLst>
-          </p:cNvPr>
-          <p:cNvSpPr>
-            <a:spLocks noGrp="1"/>
-          </p:cNvSpPr>
+            <a:pPr marL="0" indent="0">
+              <a:buNone/>
+            </a:pPr>
+            <a:r>
+              <a:rPr lang="en" sz="3333" b="1" u="sng"/>
+              <a:t>Problem 1 Assessment</a:t>
+            </a:r>
+            <a:endParaRPr sz="3333" b="1" u="sng"/>
+          </a:p>
+          <a:p>
+            <a:pPr marL="0" indent="0">
+              <a:spcBef>
+                <a:spcPts val="1600"/>
+              </a:spcBef>
+              <a:buNone/>
+            </a:pPr>
+            <a:endParaRPr/>
+          </a:p>
+          <a:p>
+            <a:pPr marL="0" indent="0">
+              <a:spcBef>
+                <a:spcPts val="1600"/>
+              </a:spcBef>
+              <a:spcAft>
+                <a:spcPts val="1600"/>
+              </a:spcAft>
+              <a:buNone/>
+            </a:pPr>
+            <a:endParaRPr/>
+          </a:p>
+        </p:txBody>
+      </p:sp>
+      <p:graphicFrame>
+        <p:nvGraphicFramePr>
+          <p:cNvPr id="65" name="Google Shape;65;p15"/>
+          <p:cNvGraphicFramePr/>
           <p:nvPr>
-            <p:ph type="body" sz="quarter" idx="11"/>
+            <p:extLst>
+              <p:ext uri="{D42A27DB-BD31-4B8C-83A1-F6EECF244321}">
+                <p14:modId xmlns:p14="http://schemas.microsoft.com/office/powerpoint/2010/main" val="1828954826"/>
+              </p:ext>
+            </p:extLst>
           </p:nvPr>
-        </p:nvSpPr>
-        <p:spPr/>
-        <p:txBody>
-          <a:bodyPr/>
-          <a:lstStyle/>
-          <a:p>
-            <a:pPr marL="457200" indent="-457200">
-              <a:buFont typeface="Arial" panose="020B0604020202020204" pitchFamily="34" charset="0"/>
-              <a:buChar char="•"/>
-            </a:pPr>
-            <a:r>
-              <a:rPr lang="en-US" dirty="0"/>
-              <a:t>Utilize the </a:t>
-            </a:r>
-            <a:r>
-              <a:rPr lang="en-US" dirty="0" err="1"/>
-              <a:t>os</a:t>
-            </a:r>
-            <a:r>
-              <a:rPr lang="en-US" dirty="0"/>
-              <a:t> and </a:t>
-            </a:r>
-            <a:r>
-              <a:rPr lang="en-US" dirty="0" err="1"/>
-              <a:t>pathlib.Path</a:t>
-            </a:r>
-            <a:r>
-              <a:rPr lang="en-US" dirty="0"/>
-              <a:t> modules to navigate a filesystem</a:t>
-            </a:r>
-          </a:p>
-          <a:p>
-            <a:pPr marL="457200" indent="-457200">
-              <a:buFont typeface="Arial" panose="020B0604020202020204" pitchFamily="34" charset="0"/>
-              <a:buChar char="•"/>
-            </a:pPr>
-            <a:r>
-              <a:rPr lang="en-US" dirty="0"/>
-              <a:t>Utilize standard python functions to manipulate files</a:t>
-            </a:r>
-          </a:p>
-        </p:txBody>
-      </p:sp>
+        </p:nvGraphicFramePr>
+        <p:xfrm>
+          <a:off x="1270000" y="1254580"/>
+          <a:ext cx="9652000" cy="5318520"/>
+        </p:xfrm>
+        <a:graphic>
+          <a:graphicData uri="http://schemas.openxmlformats.org/drawingml/2006/table">
+            <a:tbl>
+              <a:tblPr>
+                <a:noFill/>
+              </a:tblPr>
+              <a:tblGrid>
+                <a:gridCol w="1303533">
+                  <a:extLst>
+                    <a:ext uri="{9D8B030D-6E8A-4147-A177-3AD203B41FA5}">
+                      <a16:colId xmlns:a16="http://schemas.microsoft.com/office/drawing/2014/main" val="20000"/>
+                    </a:ext>
+                  </a:extLst>
+                </a:gridCol>
+                <a:gridCol w="8348467">
+                  <a:extLst>
+                    <a:ext uri="{9D8B030D-6E8A-4147-A177-3AD203B41FA5}">
+                      <a16:colId xmlns:a16="http://schemas.microsoft.com/office/drawing/2014/main" val="20001"/>
+                    </a:ext>
+                  </a:extLst>
+                </a:gridCol>
+              </a:tblGrid>
+              <a:tr h="589240">
+                <a:tc>
+                  <a:txBody>
+                    <a:bodyPr/>
+                    <a:lstStyle/>
+                    <a:p>
+                      <a:pPr marL="0" lvl="0" indent="0" algn="l" rtl="0">
+                        <a:spcBef>
+                          <a:spcPts val="0"/>
+                        </a:spcBef>
+                        <a:spcAft>
+                          <a:spcPts val="0"/>
+                        </a:spcAft>
+                        <a:buNone/>
+                      </a:pPr>
+                      <a:r>
+                        <a:rPr lang="en" sz="2300"/>
+                        <a:t>Grade</a:t>
+                      </a:r>
+                      <a:endParaRPr sz="2300"/>
+                    </a:p>
+                  </a:txBody>
+                  <a:tcPr marL="121900" marR="121900" marT="121900" marB="121900"/>
+                </a:tc>
+                <a:tc>
+                  <a:txBody>
+                    <a:bodyPr/>
+                    <a:lstStyle/>
+                    <a:p>
+                      <a:pPr marL="0" lvl="0" indent="0" algn="l" rtl="0">
+                        <a:spcBef>
+                          <a:spcPts val="0"/>
+                        </a:spcBef>
+                        <a:spcAft>
+                          <a:spcPts val="0"/>
+                        </a:spcAft>
+                        <a:buNone/>
+                      </a:pPr>
+                      <a:r>
+                        <a:rPr lang="en" sz="2300"/>
+                        <a:t>Criteria</a:t>
+                      </a:r>
+                      <a:endParaRPr sz="2300"/>
+                    </a:p>
+                  </a:txBody>
+                  <a:tcPr marL="121900" marR="121900" marT="121900" marB="121900"/>
+                </a:tc>
+                <a:extLst>
+                  <a:ext uri="{0D108BD9-81ED-4DB2-BD59-A6C34878D82A}">
+                    <a16:rowId xmlns:a16="http://schemas.microsoft.com/office/drawing/2014/main" val="10000"/>
+                  </a:ext>
+                </a:extLst>
+              </a:tr>
+              <a:tr h="589240">
+                <a:tc>
+                  <a:txBody>
+                    <a:bodyPr/>
+                    <a:lstStyle/>
+                    <a:p>
+                      <a:pPr marL="0" lvl="0" indent="0" algn="l" rtl="0">
+                        <a:spcBef>
+                          <a:spcPts val="0"/>
+                        </a:spcBef>
+                        <a:spcAft>
+                          <a:spcPts val="0"/>
+                        </a:spcAft>
+                        <a:buNone/>
+                      </a:pPr>
+                      <a:r>
+                        <a:rPr lang="en" sz="2300"/>
+                        <a:t>D</a:t>
+                      </a:r>
+                      <a:endParaRPr sz="2300"/>
+                    </a:p>
+                  </a:txBody>
+                  <a:tcPr marL="121900" marR="121900" marT="121900" marB="121900"/>
+                </a:tc>
+                <a:tc>
+                  <a:txBody>
+                    <a:bodyPr/>
+                    <a:lstStyle/>
+                    <a:p>
+                      <a:pPr marL="0" lvl="0" indent="0" algn="l" rtl="0">
+                        <a:spcBef>
+                          <a:spcPts val="0"/>
+                        </a:spcBef>
+                        <a:spcAft>
+                          <a:spcPts val="0"/>
+                        </a:spcAft>
+                        <a:buNone/>
+                      </a:pPr>
+                      <a:r>
+                        <a:rPr lang="en" sz="2300"/>
+                        <a:t>You can play one game of RPS against the computer.</a:t>
+                      </a:r>
+                      <a:endParaRPr sz="2300"/>
+                    </a:p>
+                  </a:txBody>
+                  <a:tcPr marL="121900" marR="121900" marT="121900" marB="121900"/>
+                </a:tc>
+                <a:extLst>
+                  <a:ext uri="{0D108BD9-81ED-4DB2-BD59-A6C34878D82A}">
+                    <a16:rowId xmlns:a16="http://schemas.microsoft.com/office/drawing/2014/main" val="10001"/>
+                  </a:ext>
+                </a:extLst>
+              </a:tr>
+              <a:tr h="1280120">
+                <a:tc>
+                  <a:txBody>
+                    <a:bodyPr/>
+                    <a:lstStyle/>
+                    <a:p>
+                      <a:pPr marL="0" lvl="0" indent="0" algn="l" rtl="0">
+                        <a:spcBef>
+                          <a:spcPts val="0"/>
+                        </a:spcBef>
+                        <a:spcAft>
+                          <a:spcPts val="0"/>
+                        </a:spcAft>
+                        <a:buNone/>
+                      </a:pPr>
+                      <a:r>
+                        <a:rPr lang="en" sz="2300"/>
+                        <a:t>C</a:t>
+                      </a:r>
+                      <a:endParaRPr sz="2300"/>
+                    </a:p>
+                  </a:txBody>
+                  <a:tcPr marL="121900" marR="121900" marT="121900" marB="121900"/>
+                </a:tc>
+                <a:tc>
+                  <a:txBody>
+                    <a:bodyPr/>
+                    <a:lstStyle/>
+                    <a:p>
+                      <a:pPr marL="0" lvl="0" indent="0" algn="l" rtl="0">
+                        <a:spcBef>
+                          <a:spcPts val="0"/>
+                        </a:spcBef>
+                        <a:spcAft>
+                          <a:spcPts val="0"/>
+                        </a:spcAft>
+                        <a:buNone/>
+                      </a:pPr>
+                      <a:r>
+                        <a:rPr lang="en" sz="2300"/>
+                        <a:t>You can specify the number of games to play, but the computer plays all of the games without determining “best of” the number of games.</a:t>
+                      </a:r>
+                      <a:endParaRPr sz="2300"/>
+                    </a:p>
+                  </a:txBody>
+                  <a:tcPr marL="121900" marR="121900" marT="121900" marB="121900"/>
+                </a:tc>
+                <a:extLst>
+                  <a:ext uri="{0D108BD9-81ED-4DB2-BD59-A6C34878D82A}">
+                    <a16:rowId xmlns:a16="http://schemas.microsoft.com/office/drawing/2014/main" val="10002"/>
+                  </a:ext>
+                </a:extLst>
+              </a:tr>
+              <a:tr h="934680">
+                <a:tc>
+                  <a:txBody>
+                    <a:bodyPr/>
+                    <a:lstStyle/>
+                    <a:p>
+                      <a:pPr marL="0" lvl="0" indent="0" algn="l" rtl="0">
+                        <a:spcBef>
+                          <a:spcPts val="0"/>
+                        </a:spcBef>
+                        <a:spcAft>
+                          <a:spcPts val="0"/>
+                        </a:spcAft>
+                        <a:buNone/>
+                      </a:pPr>
+                      <a:r>
+                        <a:rPr lang="en" sz="2300"/>
+                        <a:t>B</a:t>
+                      </a:r>
+                      <a:endParaRPr sz="2300"/>
+                    </a:p>
+                  </a:txBody>
+                  <a:tcPr marL="121900" marR="121900" marT="121900" marB="121900"/>
+                </a:tc>
+                <a:tc>
+                  <a:txBody>
+                    <a:bodyPr/>
+                    <a:lstStyle/>
+                    <a:p>
+                      <a:pPr marL="0" lvl="0" indent="0" algn="l" rtl="0">
+                        <a:spcBef>
+                          <a:spcPts val="0"/>
+                        </a:spcBef>
+                        <a:spcAft>
+                          <a:spcPts val="0"/>
+                        </a:spcAft>
+                        <a:buNone/>
+                      </a:pPr>
+                      <a:r>
+                        <a:rPr lang="en" sz="2300"/>
+                        <a:t>Input is validated correctly, so only 1, 3, 5, 7, or 9 games can be played.</a:t>
+                      </a:r>
+                      <a:endParaRPr sz="2300"/>
+                    </a:p>
+                  </a:txBody>
+                  <a:tcPr marL="121900" marR="121900" marT="121900" marB="121900"/>
+                </a:tc>
+                <a:extLst>
+                  <a:ext uri="{0D108BD9-81ED-4DB2-BD59-A6C34878D82A}">
+                    <a16:rowId xmlns:a16="http://schemas.microsoft.com/office/drawing/2014/main" val="10003"/>
+                  </a:ext>
+                </a:extLst>
+              </a:tr>
+              <a:tr h="1280120">
+                <a:tc>
+                  <a:txBody>
+                    <a:bodyPr/>
+                    <a:lstStyle/>
+                    <a:p>
+                      <a:pPr marL="0" lvl="0" indent="0" algn="l" rtl="0">
+                        <a:spcBef>
+                          <a:spcPts val="0"/>
+                        </a:spcBef>
+                        <a:spcAft>
+                          <a:spcPts val="0"/>
+                        </a:spcAft>
+                        <a:buNone/>
+                      </a:pPr>
+                      <a:r>
+                        <a:rPr lang="en" sz="2300"/>
+                        <a:t>A</a:t>
+                      </a:r>
+                      <a:endParaRPr sz="2300"/>
+                    </a:p>
+                  </a:txBody>
+                  <a:tcPr marL="121900" marR="121900" marT="121900" marB="121900"/>
+                </a:tc>
+                <a:tc>
+                  <a:txBody>
+                    <a:bodyPr/>
+                    <a:lstStyle/>
+                    <a:p>
+                      <a:pPr marL="0" lvl="0" indent="0" algn="l" rtl="0">
+                        <a:spcBef>
+                          <a:spcPts val="0"/>
+                        </a:spcBef>
+                        <a:spcAft>
+                          <a:spcPts val="0"/>
+                        </a:spcAft>
+                        <a:buNone/>
+                      </a:pPr>
+                      <a:r>
+                        <a:rPr lang="en" sz="2300"/>
+                        <a:t>Input is validated correctly, and the game incorporates best-of analysis (i.e. if the user wants to play 3 games and wins the first 2, the third game will not be played.</a:t>
+                      </a:r>
+                      <a:endParaRPr sz="2300"/>
+                    </a:p>
+                  </a:txBody>
+                  <a:tcPr marL="121900" marR="121900" marT="121900" marB="121900"/>
+                </a:tc>
+                <a:extLst>
+                  <a:ext uri="{0D108BD9-81ED-4DB2-BD59-A6C34878D82A}">
+                    <a16:rowId xmlns:a16="http://schemas.microsoft.com/office/drawing/2014/main" val="10004"/>
+                  </a:ext>
+                </a:extLst>
+              </a:tr>
+              <a:tr h="589240">
+                <a:tc>
+                  <a:txBody>
+                    <a:bodyPr/>
+                    <a:lstStyle/>
+                    <a:p>
+                      <a:pPr marL="0" lvl="0" indent="0" algn="l" rtl="0">
+                        <a:spcBef>
+                          <a:spcPts val="0"/>
+                        </a:spcBef>
+                        <a:spcAft>
+                          <a:spcPts val="0"/>
+                        </a:spcAft>
+                        <a:buNone/>
+                      </a:pPr>
+                      <a:r>
+                        <a:rPr lang="en" sz="2300"/>
+                        <a:t>A+</a:t>
+                      </a:r>
+                      <a:endParaRPr sz="2300"/>
+                    </a:p>
+                  </a:txBody>
+                  <a:tcPr marL="121900" marR="121900" marT="121900" marB="121900"/>
+                </a:tc>
+                <a:tc>
+                  <a:txBody>
+                    <a:bodyPr/>
+                    <a:lstStyle/>
+                    <a:p>
+                      <a:pPr marL="0" lvl="0" indent="0" algn="l" rtl="0">
+                        <a:spcBef>
+                          <a:spcPts val="0"/>
+                        </a:spcBef>
+                        <a:spcAft>
+                          <a:spcPts val="0"/>
+                        </a:spcAft>
+                        <a:buNone/>
+                      </a:pPr>
+                      <a:r>
+                        <a:rPr lang="en" sz="2300" dirty="0"/>
+                        <a:t>Added ASCII Art and delays for style</a:t>
+                      </a:r>
+                      <a:endParaRPr sz="2300" dirty="0"/>
+                    </a:p>
+                  </a:txBody>
+                  <a:tcPr marL="121900" marR="121900" marT="121900" marB="121900"/>
+                </a:tc>
+                <a:extLst>
+                  <a:ext uri="{0D108BD9-81ED-4DB2-BD59-A6C34878D82A}">
+                    <a16:rowId xmlns:a16="http://schemas.microsoft.com/office/drawing/2014/main" val="10005"/>
+                  </a:ext>
+                </a:extLst>
+              </a:tr>
+            </a:tbl>
+          </a:graphicData>
+        </a:graphic>
+      </p:graphicFrame>
     </p:spTree>
-    <p:extLst>
-      <p:ext uri="{BB962C8B-B14F-4D97-AF65-F5344CB8AC3E}">
-        <p14:creationId xmlns:p14="http://schemas.microsoft.com/office/powerpoint/2010/main" val="3616642083"/>
-      </p:ext>
-    </p:extLst>
   </p:cSld>
   <p:clrMapOvr>
     <a:masterClrMapping/>
@@ -53657,7 +55811,7 @@
   <p:cSld>
     <p:spTree>
       <p:nvGrpSpPr>
-        <p:cNvPr id="1" name=""/>
+        <p:cNvPr id="1" name="Shape 69"/>
         <p:cNvGrpSpPr/>
         <p:nvPr/>
       </p:nvGrpSpPr>
@@ -53671,91 +55825,180 @@
       </p:grpSpPr>
       <p:sp>
         <p:nvSpPr>
-          <p:cNvPr id="5" name="Title 4">
-            <a:extLst>
-              <a:ext uri="{FF2B5EF4-FFF2-40B4-BE49-F238E27FC236}">
-                <a16:creationId xmlns:a16="http://schemas.microsoft.com/office/drawing/2014/main" id="{C09D6BAA-9655-19E9-C6CF-82D4EC658E94}"/>
-              </a:ext>
-            </a:extLst>
-          </p:cNvPr>
-          <p:cNvSpPr>
+          <p:cNvPr id="70" name="Google Shape;70;p16"/>
+          <p:cNvSpPr txBox="1">
             <a:spLocks noGrp="1"/>
           </p:cNvSpPr>
           <p:nvPr>
-            <p:ph type="title"/>
+            <p:ph type="body" idx="1"/>
           </p:nvPr>
         </p:nvSpPr>
-        <p:spPr/>
-        <p:txBody>
-          <a:bodyPr/>
-          <a:lstStyle/>
-          <a:p>
-            <a:r>
-              <a:rPr lang="en-US" dirty="0"/>
-              <a:t>OS module</a:t>
-            </a:r>
-          </a:p>
-        </p:txBody>
-      </p:sp>
-      <p:sp>
-        <p:nvSpPr>
-          <p:cNvPr id="3" name="TextBox 2">
-            <a:extLst>
-              <a:ext uri="{FF2B5EF4-FFF2-40B4-BE49-F238E27FC236}">
-                <a16:creationId xmlns:a16="http://schemas.microsoft.com/office/drawing/2014/main" id="{CBEAAC7B-2455-0DE6-A3BC-5EE8916C5C2B}"/>
-              </a:ext>
-            </a:extLst>
-          </p:cNvPr>
-          <p:cNvSpPr txBox="1"/>
-          <p:nvPr/>
-        </p:nvSpPr>
         <p:spPr>
           <a:xfrm>
-            <a:off x="1568919" y="2644170"/>
-            <a:ext cx="9452008" cy="1569660"/>
+            <a:off x="415600" y="284900"/>
+            <a:ext cx="11360800" cy="6323600"/>
           </a:xfrm>
           <a:prstGeom prst="rect">
             <a:avLst/>
           </a:prstGeom>
-          <a:noFill/>
-        </p:spPr>
-        <p:txBody>
-          <a:bodyPr wrap="square">
-            <a:spAutoFit/>
+        </p:spPr>
+        <p:txBody>
+          <a:bodyPr spcFirstLastPara="1" vert="horz" wrap="square" lIns="121900" tIns="121900" rIns="121900" bIns="121900" spcCol="365760" rtlCol="0" anchor="t" anchorCtr="0">
+            <a:noAutofit/>
           </a:bodyPr>
           <a:lstStyle/>
           <a:p>
-            <a:pPr>
+            <a:pPr marL="0" indent="0">
               <a:buNone/>
             </a:pPr>
             <a:r>
-              <a:rPr lang="en-US" sz="2400" dirty="0">
-                <a:effectLst/>
-              </a:rPr>
-              <a:t>The </a:t>
-            </a:r>
-            <a:r>
-              <a:rPr lang="en-US" sz="2400" dirty="0" err="1">
-                <a:effectLst/>
-                <a:latin typeface="Courier New" panose="02070309020205020404" pitchFamily="49" charset="0"/>
-              </a:rPr>
-              <a:t>os</a:t>
-            </a:r>
-            <a:r>
-              <a:rPr lang="en-US" sz="2400" dirty="0">
-                <a:effectLst/>
-              </a:rPr>
-              <a:t> module in Python provides a way to interact with the operating system. It offers a portable interface for OS-dependent functionality, meaning your code can work across different platforms (Windows, macOS, Linux) without major changes.</a:t>
-            </a:r>
+              <a:rPr lang="en" sz="2000" b="1" u="sng" dirty="0"/>
+              <a:t>Pre Class Problem 2 - Pizza Shop Shenanigans (20 min)</a:t>
+            </a:r>
+            <a:endParaRPr sz="2000" b="1" u="sng" dirty="0"/>
+          </a:p>
+          <a:p>
+            <a:pPr marL="0" indent="0">
+              <a:spcBef>
+                <a:spcPts val="1600"/>
+              </a:spcBef>
+              <a:buNone/>
+            </a:pPr>
+            <a:r>
+              <a:rPr lang="en" sz="2000" dirty="0"/>
+              <a:t>Your local pizza shop (“Byte da Pi”) is rolling out so-called ‘deals’ on the regular, but you’ve become suspicious if they are </a:t>
+            </a:r>
+            <a:r>
+              <a:rPr lang="en" sz="2000" i="1" dirty="0"/>
+              <a:t>actually deals</a:t>
+            </a:r>
+            <a:r>
+              <a:rPr lang="en" sz="2000" dirty="0"/>
+              <a:t>.</a:t>
+            </a:r>
+            <a:endParaRPr sz="2000" dirty="0"/>
+          </a:p>
+          <a:p>
+            <a:pPr marL="0" indent="0">
+              <a:spcBef>
+                <a:spcPts val="1600"/>
+              </a:spcBef>
+              <a:buNone/>
+            </a:pPr>
+            <a:r>
+              <a:rPr lang="en" sz="2000" dirty="0"/>
+              <a:t>For instance, this week Byte da Pi is offering two small pizzas (10” diameter) for $19.99.  However, their regular priced large pizza (16” diameter) is priced $20.99.  Are the two small pizzas really a deal at $19.99?</a:t>
+            </a:r>
+            <a:endParaRPr sz="2000" dirty="0"/>
+          </a:p>
+          <a:p>
+            <a:pPr marL="0" indent="0">
+              <a:spcBef>
+                <a:spcPts val="1600"/>
+              </a:spcBef>
+              <a:buNone/>
+            </a:pPr>
+            <a:r>
+              <a:rPr lang="en" sz="2000" dirty="0"/>
+              <a:t>Implied:  You need to determine the area of the pizzas.</a:t>
+            </a:r>
+            <a:endParaRPr sz="2000" dirty="0"/>
+          </a:p>
+          <a:p>
+            <a:pPr marL="0" indent="0">
+              <a:spcBef>
+                <a:spcPts val="1600"/>
+              </a:spcBef>
+              <a:buNone/>
+            </a:pPr>
+            <a:r>
+              <a:rPr lang="en" sz="2000" dirty="0"/>
+              <a:t>Solve for this specific deal, and then create two functions to help you solve for </a:t>
+            </a:r>
+            <a:r>
+              <a:rPr lang="en" sz="2000" i="1" dirty="0"/>
+              <a:t>any</a:t>
+            </a:r>
+            <a:r>
+              <a:rPr lang="en" sz="2000" dirty="0"/>
+              <a:t> deal.</a:t>
+            </a:r>
+            <a:endParaRPr sz="2000" dirty="0"/>
+          </a:p>
+          <a:p>
+            <a:pPr marL="0" indent="0">
+              <a:spcBef>
+                <a:spcPts val="1600"/>
+              </a:spcBef>
+              <a:buNone/>
+            </a:pPr>
+            <a:r>
+              <a:rPr lang="en" sz="2000" dirty="0"/>
+              <a:t>The first function should determine the price per square inch of pizza.  </a:t>
+            </a:r>
+            <a:r>
+              <a:rPr lang="en" sz="2000" b="1" dirty="0"/>
+              <a:t>How many parameters will this function have?</a:t>
+            </a:r>
+            <a:endParaRPr sz="2000" b="1" dirty="0"/>
+          </a:p>
+          <a:p>
+            <a:pPr marL="0" indent="0">
+              <a:spcBef>
+                <a:spcPts val="1600"/>
+              </a:spcBef>
+              <a:buNone/>
+            </a:pPr>
+            <a:r>
+              <a:rPr lang="en" sz="2000" dirty="0"/>
+              <a:t>The second function should compare deals based on $/in</a:t>
+            </a:r>
+            <a:r>
+              <a:rPr lang="en" sz="2000" baseline="30000" dirty="0"/>
+              <a:t>2</a:t>
+            </a:r>
+            <a:r>
+              <a:rPr lang="en" sz="2000" dirty="0"/>
+              <a:t> and quantity of pizzas offered in the deal.  </a:t>
+            </a:r>
+            <a:r>
+              <a:rPr lang="en" sz="2000" b="1" dirty="0"/>
+              <a:t>This function should have four parameters. What are they?</a:t>
+            </a:r>
+            <a:endParaRPr sz="2000" b="1" dirty="0"/>
+          </a:p>
+          <a:p>
+            <a:pPr marL="0" indent="0">
+              <a:spcBef>
+                <a:spcPts val="1600"/>
+              </a:spcBef>
+              <a:buNone/>
+            </a:pPr>
+            <a:r>
+              <a:rPr lang="en" sz="2000" b="1" dirty="0"/>
+              <a:t>BONUS:  </a:t>
+            </a:r>
+            <a:r>
+              <a:rPr lang="en" sz="2000" dirty="0"/>
+              <a:t>If your program finds it to be a good deal, your python script should open the webpage of a local pizza shop.  If your program finds it to be a bad deal, tell the user, and open the webpage of a pizza chain (Dominoes/Papa Johns…).  Also add ASCII Art.</a:t>
+            </a:r>
+            <a:endParaRPr sz="2000" dirty="0"/>
+          </a:p>
+          <a:p>
+            <a:pPr marL="0" indent="0">
+              <a:spcBef>
+                <a:spcPts val="1600"/>
+              </a:spcBef>
+              <a:spcAft>
+                <a:spcPts val="1600"/>
+              </a:spcAft>
+              <a:buNone/>
+            </a:pPr>
+            <a:endParaRPr sz="600" dirty="0"/>
           </a:p>
         </p:txBody>
       </p:sp>
     </p:spTree>
-    <p:extLst>
-      <p:ext uri="{BB962C8B-B14F-4D97-AF65-F5344CB8AC3E}">
-        <p14:creationId xmlns:p14="http://schemas.microsoft.com/office/powerpoint/2010/main" val="3047554373"/>
-      </p:ext>
-    </p:extLst>
   </p:cSld>
   <p:clrMapOvr>
     <a:masterClrMapping/>

</xml_diff>